<commit_message>
Round 2: eyebrow spacing, closed quote, clearer tool notes
Event line and Up next eyebrow move to y 200 on cover layouts. Quote closes its quotation mark. HTML decks go to decks/<talk-slug>.html so ../ paths keep working. Google Slides is one option, not the recommended one.

Co-Authored-By: Claude Fable 5.1 <noreply@anthropic.com>
</commit_message>
<xml_diff>
--- a/template/buidlguidl-devcon8.pptx
+++ b/template/buidlguidl-devcon8.pptx
@@ -154,7 +154,7 @@
         </p:nvSpPr>
         <p:spPr>
           <a:xfrm>
-            <a:off x="762000" y="1371600"/>
+            <a:off x="762000" y="1270000"/>
             <a:ext cx="6350000" cy="298450"/>
           </a:xfrm>
           <a:prstGeom prst="rect">
@@ -393,7 +393,7 @@
         </p:nvSpPr>
         <p:spPr>
           <a:xfrm>
-            <a:off x="762000" y="1371600"/>
+            <a:off x="762000" y="1270000"/>
             <a:ext cx="6350000" cy="298450"/>
           </a:xfrm>
           <a:prstGeom prst="rect">
@@ -682,7 +682,7 @@
         </p:nvSpPr>
         <p:spPr>
           <a:xfrm>
-            <a:off x="762000" y="1371600"/>
+            <a:off x="762000" y="1270000"/>
             <a:ext cx="6350000" cy="298450"/>
           </a:xfrm>
           <a:prstGeom prst="rect">

</xml_diff>

<commit_message>
Google Slides first: Space Grotesk headings, Machina removed
Co-Authored-By: Claude Fable 5.1 <noreply@anthropic.com>
</commit_message>
<xml_diff>
--- a/template/buidlguidl-devcon8.pptx
+++ b/template/buidlguidl-devcon8.pptx
@@ -225,13 +225,13 @@
                 <a:spcPts val="0"/>
               </a:spcBef>
               <a:buNone/>
-              <a:defRPr sz="4800" b="0">
+              <a:defRPr sz="4800" b="1">
                 <a:solidFill>
                   <a:srgbClr val="182232"/>
                 </a:solidFill>
-                <a:latin typeface="PP Neue Machina Inktrap Smbold"/>
-                <a:ea typeface="PP Neue Machina Inktrap Smbold"/>
-                <a:cs typeface="PP Neue Machina Inktrap Smbold"/>
+                <a:latin typeface="Space Grotesk"/>
+                <a:ea typeface="Space Grotesk"/>
+                <a:cs typeface="Space Grotesk"/>
               </a:defRPr>
             </a:lvl1pPr>
           </a:lstStyle>
@@ -464,13 +464,13 @@
                 <a:spcPts val="0"/>
               </a:spcBef>
               <a:buNone/>
-              <a:defRPr sz="4800" b="0">
+              <a:defRPr sz="4800" b="1">
                 <a:solidFill>
                   <a:srgbClr val="182232"/>
                 </a:solidFill>
-                <a:latin typeface="PP Neue Machina Inktrap Smbold"/>
-                <a:ea typeface="PP Neue Machina Inktrap Smbold"/>
-                <a:cs typeface="PP Neue Machina Inktrap Smbold"/>
+                <a:latin typeface="Space Grotesk"/>
+                <a:ea typeface="Space Grotesk"/>
+                <a:cs typeface="Space Grotesk"/>
               </a:defRPr>
             </a:lvl1pPr>
           </a:lstStyle>
@@ -753,13 +753,13 @@
                 <a:spcPts val="0"/>
               </a:spcBef>
               <a:buNone/>
-              <a:defRPr sz="4800" b="0">
+              <a:defRPr sz="4800" b="1">
                 <a:solidFill>
                   <a:srgbClr val="182232"/>
                 </a:solidFill>
-                <a:latin typeface="PP Neue Machina Inktrap Smbold"/>
-                <a:ea typeface="PP Neue Machina Inktrap Smbold"/>
-                <a:cs typeface="PP Neue Machina Inktrap Smbold"/>
+                <a:latin typeface="Space Grotesk"/>
+                <a:ea typeface="Space Grotesk"/>
+                <a:cs typeface="Space Grotesk"/>
               </a:defRPr>
             </a:lvl1pPr>
           </a:lstStyle>
@@ -945,13 +945,13 @@
                 <a:spcPts val="0"/>
               </a:spcBef>
               <a:buNone/>
-              <a:defRPr sz="6000" b="0">
+              <a:defRPr sz="6000" b="1">
                 <a:solidFill>
                   <a:srgbClr val="182232"/>
                 </a:solidFill>
-                <a:latin typeface="PP Neue Machina Inktrap Smbold"/>
-                <a:ea typeface="PP Neue Machina Inktrap Smbold"/>
-                <a:cs typeface="PP Neue Machina Inktrap Smbold"/>
+                <a:latin typeface="Space Grotesk"/>
+                <a:ea typeface="Space Grotesk"/>
+                <a:cs typeface="Space Grotesk"/>
               </a:defRPr>
             </a:lvl1pPr>
           </a:lstStyle>
@@ -1087,13 +1087,13 @@
                 <a:spcPts val="0"/>
               </a:spcBef>
               <a:buNone/>
-              <a:defRPr sz="4000" b="0">
+              <a:defRPr sz="4000" b="1">
                 <a:solidFill>
                   <a:srgbClr val="182232"/>
                 </a:solidFill>
-                <a:latin typeface="PP Neue Machina Inktrap Smbold"/>
-                <a:ea typeface="PP Neue Machina Inktrap Smbold"/>
-                <a:cs typeface="PP Neue Machina Inktrap Smbold"/>
+                <a:latin typeface="Space Grotesk"/>
+                <a:ea typeface="Space Grotesk"/>
+                <a:cs typeface="Space Grotesk"/>
               </a:defRPr>
             </a:lvl1pPr>
           </a:lstStyle>
@@ -1234,13 +1234,13 @@
                 <a:spcPts val="0"/>
               </a:spcBef>
               <a:buNone/>
-              <a:defRPr sz="4000" b="0">
+              <a:defRPr sz="4000" b="1">
                 <a:solidFill>
                   <a:srgbClr val="182232"/>
                 </a:solidFill>
-                <a:latin typeface="PP Neue Machina Inktrap Smbold"/>
-                <a:ea typeface="PP Neue Machina Inktrap Smbold"/>
-                <a:cs typeface="PP Neue Machina Inktrap Smbold"/>
+                <a:latin typeface="Space Grotesk"/>
+                <a:ea typeface="Space Grotesk"/>
+                <a:cs typeface="Space Grotesk"/>
               </a:defRPr>
             </a:lvl1pPr>
           </a:lstStyle>
@@ -1375,13 +1375,13 @@
                 <a:spcPts val="0"/>
               </a:spcBef>
               <a:buNone/>
-              <a:defRPr sz="4000" b="0">
+              <a:defRPr sz="4000" b="1">
                 <a:solidFill>
                   <a:srgbClr val="182232"/>
                 </a:solidFill>
-                <a:latin typeface="PP Neue Machina Inktrap Smbold"/>
-                <a:ea typeface="PP Neue Machina Inktrap Smbold"/>
-                <a:cs typeface="PP Neue Machina Inktrap Smbold"/>
+                <a:latin typeface="Space Grotesk"/>
+                <a:ea typeface="Space Grotesk"/>
+                <a:cs typeface="Space Grotesk"/>
               </a:defRPr>
             </a:lvl1pPr>
           </a:lstStyle>
@@ -2132,13 +2132,13 @@
                 <a:spcPts val="0"/>
               </a:spcBef>
               <a:buNone/>
-              <a:defRPr sz="6000" b="0">
+              <a:defRPr sz="6000" b="1">
                 <a:solidFill>
                   <a:srgbClr val="182232"/>
                 </a:solidFill>
-                <a:latin typeface="PP Neue Machina Inktrap Smbold"/>
-                <a:ea typeface="PP Neue Machina Inktrap Smbold"/>
-                <a:cs typeface="PP Neue Machina Inktrap Smbold"/>
+                <a:latin typeface="Space Grotesk"/>
+                <a:ea typeface="Space Grotesk"/>
+                <a:cs typeface="Space Grotesk"/>
               </a:defRPr>
             </a:lvl1pPr>
           </a:lstStyle>
@@ -2224,13 +2224,13 @@
                 <a:spcPts val="0"/>
               </a:spcBef>
               <a:buNone/>
-              <a:defRPr sz="4000" b="0">
+              <a:defRPr sz="4000" b="1">
                 <a:solidFill>
                   <a:srgbClr val="FFFCFC"/>
                 </a:solidFill>
-                <a:latin typeface="PP Neue Machina Inktrap Smbold"/>
-                <a:ea typeface="PP Neue Machina Inktrap Smbold"/>
-                <a:cs typeface="PP Neue Machina Inktrap Smbold"/>
+                <a:latin typeface="Space Grotesk"/>
+                <a:ea typeface="Space Grotesk"/>
+                <a:cs typeface="Space Grotesk"/>
               </a:defRPr>
             </a:lvl1pPr>
           </a:lstStyle>
@@ -2416,13 +2416,13 @@
                 <a:spcPts val="0"/>
               </a:spcBef>
               <a:buNone/>
-              <a:defRPr sz="4000" b="0">
+              <a:defRPr sz="4000" b="1">
                 <a:solidFill>
                   <a:srgbClr val="182232"/>
                 </a:solidFill>
-                <a:latin typeface="PP Neue Machina Inktrap Smbold"/>
-                <a:ea typeface="PP Neue Machina Inktrap Smbold"/>
-                <a:cs typeface="PP Neue Machina Inktrap Smbold"/>
+                <a:latin typeface="Space Grotesk"/>
+                <a:ea typeface="Space Grotesk"/>
+                <a:cs typeface="Space Grotesk"/>
               </a:defRPr>
             </a:lvl1pPr>
           </a:lstStyle>
@@ -2635,13 +2635,13 @@
                 <a:spcPts val="0"/>
               </a:spcBef>
               <a:buNone/>
-              <a:defRPr sz="4000" b="0">
+              <a:defRPr sz="4000" b="1">
                 <a:solidFill>
                   <a:srgbClr val="182232"/>
                 </a:solidFill>
-                <a:latin typeface="PP Neue Machina Inktrap Smbold"/>
-                <a:ea typeface="PP Neue Machina Inktrap Smbold"/>
-                <a:cs typeface="PP Neue Machina Inktrap Smbold"/>
+                <a:latin typeface="Space Grotesk"/>
+                <a:ea typeface="Space Grotesk"/>
+                <a:cs typeface="Space Grotesk"/>
               </a:defRPr>
             </a:lvl1pPr>
           </a:lstStyle>
@@ -3507,12 +3507,12 @@
         </p:nvSpPr>
         <p:spPr>
           <a:xfrm>
-            <a:off x="3117850" y="2724150"/>
-            <a:ext cx="4806950" cy="768350"/>
+            <a:off x="2990850" y="2603500"/>
+            <a:ext cx="4254500" cy="996950"/>
           </a:xfrm>
           <a:prstGeom prst="roundRect">
             <a:avLst>
-              <a:gd name="adj" fmla="val 14049"/>
+              <a:gd name="adj" fmla="val 10828"/>
             </a:avLst>
           </a:prstGeom>
           <a:solidFill>
@@ -4682,7 +4682,7 @@
     </a:clrScheme>
     <a:fontScheme name="Office">
       <a:majorFont>
-        <a:latin typeface="PP Neue Machina Inktrap Smbold"/>
+        <a:latin typeface="Space Grotesk"/>
         <a:ea typeface=""/>
         <a:cs typeface=""/>
         <a:font script="Jpan" typeface="ＭＳ Ｐゴシック"/>

</xml_diff>

<commit_message>
Revert "Google Slides first: Space Grotesk headings, Machina removed"
This reverts commit 58f30152524ac39ef3a18398132f25ab72bd5f5b.
</commit_message>
<xml_diff>
--- a/template/buidlguidl-devcon8.pptx
+++ b/template/buidlguidl-devcon8.pptx
@@ -225,13 +225,13 @@
                 <a:spcPts val="0"/>
               </a:spcBef>
               <a:buNone/>
-              <a:defRPr sz="4800" b="1">
+              <a:defRPr sz="4800" b="0">
                 <a:solidFill>
                   <a:srgbClr val="182232"/>
                 </a:solidFill>
-                <a:latin typeface="Space Grotesk"/>
-                <a:ea typeface="Space Grotesk"/>
-                <a:cs typeface="Space Grotesk"/>
+                <a:latin typeface="PP Neue Machina Inktrap Smbold"/>
+                <a:ea typeface="PP Neue Machina Inktrap Smbold"/>
+                <a:cs typeface="PP Neue Machina Inktrap Smbold"/>
               </a:defRPr>
             </a:lvl1pPr>
           </a:lstStyle>
@@ -464,13 +464,13 @@
                 <a:spcPts val="0"/>
               </a:spcBef>
               <a:buNone/>
-              <a:defRPr sz="4800" b="1">
+              <a:defRPr sz="4800" b="0">
                 <a:solidFill>
                   <a:srgbClr val="182232"/>
                 </a:solidFill>
-                <a:latin typeface="Space Grotesk"/>
-                <a:ea typeface="Space Grotesk"/>
-                <a:cs typeface="Space Grotesk"/>
+                <a:latin typeface="PP Neue Machina Inktrap Smbold"/>
+                <a:ea typeface="PP Neue Machina Inktrap Smbold"/>
+                <a:cs typeface="PP Neue Machina Inktrap Smbold"/>
               </a:defRPr>
             </a:lvl1pPr>
           </a:lstStyle>
@@ -753,13 +753,13 @@
                 <a:spcPts val="0"/>
               </a:spcBef>
               <a:buNone/>
-              <a:defRPr sz="4800" b="1">
+              <a:defRPr sz="4800" b="0">
                 <a:solidFill>
                   <a:srgbClr val="182232"/>
                 </a:solidFill>
-                <a:latin typeface="Space Grotesk"/>
-                <a:ea typeface="Space Grotesk"/>
-                <a:cs typeface="Space Grotesk"/>
+                <a:latin typeface="PP Neue Machina Inktrap Smbold"/>
+                <a:ea typeface="PP Neue Machina Inktrap Smbold"/>
+                <a:cs typeface="PP Neue Machina Inktrap Smbold"/>
               </a:defRPr>
             </a:lvl1pPr>
           </a:lstStyle>
@@ -945,13 +945,13 @@
                 <a:spcPts val="0"/>
               </a:spcBef>
               <a:buNone/>
-              <a:defRPr sz="6000" b="1">
+              <a:defRPr sz="6000" b="0">
                 <a:solidFill>
                   <a:srgbClr val="182232"/>
                 </a:solidFill>
-                <a:latin typeface="Space Grotesk"/>
-                <a:ea typeface="Space Grotesk"/>
-                <a:cs typeface="Space Grotesk"/>
+                <a:latin typeface="PP Neue Machina Inktrap Smbold"/>
+                <a:ea typeface="PP Neue Machina Inktrap Smbold"/>
+                <a:cs typeface="PP Neue Machina Inktrap Smbold"/>
               </a:defRPr>
             </a:lvl1pPr>
           </a:lstStyle>
@@ -1087,13 +1087,13 @@
                 <a:spcPts val="0"/>
               </a:spcBef>
               <a:buNone/>
-              <a:defRPr sz="4000" b="1">
+              <a:defRPr sz="4000" b="0">
                 <a:solidFill>
                   <a:srgbClr val="182232"/>
                 </a:solidFill>
-                <a:latin typeface="Space Grotesk"/>
-                <a:ea typeface="Space Grotesk"/>
-                <a:cs typeface="Space Grotesk"/>
+                <a:latin typeface="PP Neue Machina Inktrap Smbold"/>
+                <a:ea typeface="PP Neue Machina Inktrap Smbold"/>
+                <a:cs typeface="PP Neue Machina Inktrap Smbold"/>
               </a:defRPr>
             </a:lvl1pPr>
           </a:lstStyle>
@@ -1234,13 +1234,13 @@
                 <a:spcPts val="0"/>
               </a:spcBef>
               <a:buNone/>
-              <a:defRPr sz="4000" b="1">
+              <a:defRPr sz="4000" b="0">
                 <a:solidFill>
                   <a:srgbClr val="182232"/>
                 </a:solidFill>
-                <a:latin typeface="Space Grotesk"/>
-                <a:ea typeface="Space Grotesk"/>
-                <a:cs typeface="Space Grotesk"/>
+                <a:latin typeface="PP Neue Machina Inktrap Smbold"/>
+                <a:ea typeface="PP Neue Machina Inktrap Smbold"/>
+                <a:cs typeface="PP Neue Machina Inktrap Smbold"/>
               </a:defRPr>
             </a:lvl1pPr>
           </a:lstStyle>
@@ -1375,13 +1375,13 @@
                 <a:spcPts val="0"/>
               </a:spcBef>
               <a:buNone/>
-              <a:defRPr sz="4000" b="1">
+              <a:defRPr sz="4000" b="0">
                 <a:solidFill>
                   <a:srgbClr val="182232"/>
                 </a:solidFill>
-                <a:latin typeface="Space Grotesk"/>
-                <a:ea typeface="Space Grotesk"/>
-                <a:cs typeface="Space Grotesk"/>
+                <a:latin typeface="PP Neue Machina Inktrap Smbold"/>
+                <a:ea typeface="PP Neue Machina Inktrap Smbold"/>
+                <a:cs typeface="PP Neue Machina Inktrap Smbold"/>
               </a:defRPr>
             </a:lvl1pPr>
           </a:lstStyle>
@@ -2132,13 +2132,13 @@
                 <a:spcPts val="0"/>
               </a:spcBef>
               <a:buNone/>
-              <a:defRPr sz="6000" b="1">
+              <a:defRPr sz="6000" b="0">
                 <a:solidFill>
                   <a:srgbClr val="182232"/>
                 </a:solidFill>
-                <a:latin typeface="Space Grotesk"/>
-                <a:ea typeface="Space Grotesk"/>
-                <a:cs typeface="Space Grotesk"/>
+                <a:latin typeface="PP Neue Machina Inktrap Smbold"/>
+                <a:ea typeface="PP Neue Machina Inktrap Smbold"/>
+                <a:cs typeface="PP Neue Machina Inktrap Smbold"/>
               </a:defRPr>
             </a:lvl1pPr>
           </a:lstStyle>
@@ -2224,13 +2224,13 @@
                 <a:spcPts val="0"/>
               </a:spcBef>
               <a:buNone/>
-              <a:defRPr sz="4000" b="1">
+              <a:defRPr sz="4000" b="0">
                 <a:solidFill>
                   <a:srgbClr val="FFFCFC"/>
                 </a:solidFill>
-                <a:latin typeface="Space Grotesk"/>
-                <a:ea typeface="Space Grotesk"/>
-                <a:cs typeface="Space Grotesk"/>
+                <a:latin typeface="PP Neue Machina Inktrap Smbold"/>
+                <a:ea typeface="PP Neue Machina Inktrap Smbold"/>
+                <a:cs typeface="PP Neue Machina Inktrap Smbold"/>
               </a:defRPr>
             </a:lvl1pPr>
           </a:lstStyle>
@@ -2416,13 +2416,13 @@
                 <a:spcPts val="0"/>
               </a:spcBef>
               <a:buNone/>
-              <a:defRPr sz="4000" b="1">
+              <a:defRPr sz="4000" b="0">
                 <a:solidFill>
                   <a:srgbClr val="182232"/>
                 </a:solidFill>
-                <a:latin typeface="Space Grotesk"/>
-                <a:ea typeface="Space Grotesk"/>
-                <a:cs typeface="Space Grotesk"/>
+                <a:latin typeface="PP Neue Machina Inktrap Smbold"/>
+                <a:ea typeface="PP Neue Machina Inktrap Smbold"/>
+                <a:cs typeface="PP Neue Machina Inktrap Smbold"/>
               </a:defRPr>
             </a:lvl1pPr>
           </a:lstStyle>
@@ -2635,13 +2635,13 @@
                 <a:spcPts val="0"/>
               </a:spcBef>
               <a:buNone/>
-              <a:defRPr sz="4000" b="1">
+              <a:defRPr sz="4000" b="0">
                 <a:solidFill>
                   <a:srgbClr val="182232"/>
                 </a:solidFill>
-                <a:latin typeface="Space Grotesk"/>
-                <a:ea typeface="Space Grotesk"/>
-                <a:cs typeface="Space Grotesk"/>
+                <a:latin typeface="PP Neue Machina Inktrap Smbold"/>
+                <a:ea typeface="PP Neue Machina Inktrap Smbold"/>
+                <a:cs typeface="PP Neue Machina Inktrap Smbold"/>
               </a:defRPr>
             </a:lvl1pPr>
           </a:lstStyle>
@@ -3507,12 +3507,12 @@
         </p:nvSpPr>
         <p:spPr>
           <a:xfrm>
-            <a:off x="2990850" y="2603500"/>
-            <a:ext cx="4254500" cy="996950"/>
+            <a:off x="3117850" y="2724150"/>
+            <a:ext cx="4806950" cy="768350"/>
           </a:xfrm>
           <a:prstGeom prst="roundRect">
             <a:avLst>
-              <a:gd name="adj" fmla="val 10828"/>
+              <a:gd name="adj" fmla="val 14049"/>
             </a:avLst>
           </a:prstGeom>
           <a:solidFill>
@@ -4682,7 +4682,7 @@
     </a:clrScheme>
     <a:fontScheme name="Office">
       <a:majorFont>
-        <a:latin typeface="Space Grotesk"/>
+        <a:latin typeface="PP Neue Machina Inktrap Smbold"/>
         <a:ea typeface=""/>
         <a:cs typeface=""/>
         <a:font script="Jpan" typeface="ＭＳ Ｐゴシック"/>

</xml_diff>

<commit_message>
Space Grotesk headings, editable Google Slides path; Machina and picture export removed
Headings are Space Grotesk Bold (700) so every slide stays editable text in
Google Slides. PP Neue Machina leaves the repo: its licence forbids putting
it on the public internet, and the logo in the backgrounds is artwork, not
text. The picture export (build/export.py, build/export.sh, speaker-note
asides) goes; the ?slide=N fix that picks the Nth slide in document order
stays. The pptx template is now 10 x 5.625 in, the size of the Google Slides
deck Devcon gives each speaker (1 px = 4762.5 EMU = 0.375 pt), so importing
it rescales nothing. README and SKILL.md describe one path: fill the pptx or
copy the Google Slides master, then import into the Devcon link.

Co-Authored-By: Claude Fable 5.1 <noreply@anthropic.com>
</commit_message>
<xml_diff>
--- a/template/buidlguidl-devcon8.pptx
+++ b/template/buidlguidl-devcon8.pptx
@@ -17,7 +17,7 @@
     <p:sldId id="265" r:id="rId16"/>
     <p:sldId id="266" r:id="rId17"/>
   </p:sldIdLst>
-  <p:sldSz cx="12192000" cy="6858000" type="screen4x3"/>
+  <p:sldSz cx="9144000" cy="5143500" type="screen4x3"/>
   <p:notesSz cx="6858000" cy="9144000"/>
   <p:defaultTextStyle>
     <a:defPPr>
@@ -154,8 +154,8 @@
         </p:nvSpPr>
         <p:spPr>
           <a:xfrm>
-            <a:off x="762000" y="1270000"/>
-            <a:ext cx="6350000" cy="298450"/>
+            <a:off x="571500" y="952500"/>
+            <a:ext cx="4762500" cy="223838"/>
           </a:xfrm>
           <a:prstGeom prst="rect">
             <a:avLst/>
@@ -169,13 +169,13 @@
           <a:lstStyle>
             <a:lvl1pPr marL="0" indent="0" algn="l">
               <a:lnSpc>
-                <a:spcPts val="2350"/>
+                <a:spcPts val="1762"/>
               </a:lnSpc>
               <a:spcBef>
                 <a:spcPts val="0"/>
               </a:spcBef>
               <a:buNone/>
-              <a:defRPr sz="1800" b="0">
+              <a:defRPr sz="1350" b="0">
                 <a:solidFill>
                   <a:srgbClr val="182232"/>
                 </a:solidFill>
@@ -205,8 +205,8 @@
         </p:nvSpPr>
         <p:spPr>
           <a:xfrm>
-            <a:off x="762000" y="1778000"/>
-            <a:ext cx="5334000" cy="1968500"/>
+            <a:off x="571500" y="1333500"/>
+            <a:ext cx="4000500" cy="1476375"/>
           </a:xfrm>
           <a:prstGeom prst="rect">
             <a:avLst/>
@@ -219,19 +219,19 @@
           <a:lstStyle>
             <a:lvl1pPr marL="0" indent="0" algn="l">
               <a:lnSpc>
-                <a:spcPts val="5050"/>
+                <a:spcPts val="3788"/>
               </a:lnSpc>
               <a:spcBef>
                 <a:spcPts val="0"/>
               </a:spcBef>
               <a:buNone/>
-              <a:defRPr sz="4800" b="0">
+              <a:defRPr sz="3600" b="1">
                 <a:solidFill>
                   <a:srgbClr val="182232"/>
                 </a:solidFill>
-                <a:latin typeface="PP Neue Machina Inktrap Smbold"/>
-                <a:ea typeface="PP Neue Machina Inktrap Smbold"/>
-                <a:cs typeface="PP Neue Machina Inktrap Smbold"/>
+                <a:latin typeface="Space Grotesk"/>
+                <a:ea typeface="Space Grotesk"/>
+                <a:cs typeface="Space Grotesk"/>
               </a:defRPr>
             </a:lvl1pPr>
           </a:lstStyle>
@@ -255,8 +255,8 @@
         </p:nvSpPr>
         <p:spPr>
           <a:xfrm>
-            <a:off x="762000" y="3962400"/>
-            <a:ext cx="5715000" cy="393700"/>
+            <a:off x="571500" y="2971800"/>
+            <a:ext cx="4286250" cy="295275"/>
           </a:xfrm>
           <a:prstGeom prst="rect">
             <a:avLst/>
@@ -269,13 +269,13 @@
           <a:lstStyle>
             <a:lvl1pPr marL="0" indent="0" algn="l">
               <a:lnSpc>
-                <a:spcPts val="3100"/>
+                <a:spcPts val="2325"/>
               </a:lnSpc>
               <a:spcBef>
                 <a:spcPts val="0"/>
               </a:spcBef>
               <a:buNone/>
-              <a:defRPr sz="2400" b="1">
+              <a:defRPr sz="1800" b="1">
                 <a:solidFill>
                   <a:srgbClr val="182232"/>
                 </a:solidFill>
@@ -305,8 +305,8 @@
         </p:nvSpPr>
         <p:spPr>
           <a:xfrm>
-            <a:off x="762000" y="4368800"/>
-            <a:ext cx="5715000" cy="298450"/>
+            <a:off x="571500" y="3276600"/>
+            <a:ext cx="4286250" cy="223838"/>
           </a:xfrm>
           <a:prstGeom prst="rect">
             <a:avLst/>
@@ -319,13 +319,13 @@
           <a:lstStyle>
             <a:lvl1pPr marL="0" indent="0" algn="l">
               <a:lnSpc>
-                <a:spcPts val="2350"/>
+                <a:spcPts val="1762"/>
               </a:lnSpc>
               <a:spcBef>
                 <a:spcPts val="0"/>
               </a:spcBef>
               <a:buNone/>
-              <a:defRPr sz="1800" b="0">
+              <a:defRPr sz="1350" b="0">
                 <a:solidFill>
                   <a:srgbClr val="182232"/>
                 </a:solidFill>
@@ -393,8 +393,8 @@
         </p:nvSpPr>
         <p:spPr>
           <a:xfrm>
-            <a:off x="762000" y="1270000"/>
-            <a:ext cx="6350000" cy="298450"/>
+            <a:off x="571500" y="952500"/>
+            <a:ext cx="4762500" cy="223838"/>
           </a:xfrm>
           <a:prstGeom prst="rect">
             <a:avLst/>
@@ -408,7 +408,157 @@
           <a:lstStyle>
             <a:lvl1pPr marL="0" indent="0" algn="l">
               <a:lnSpc>
-                <a:spcPts val="2350"/>
+                <a:spcPts val="1762"/>
+              </a:lnSpc>
+              <a:spcBef>
+                <a:spcPts val="0"/>
+              </a:spcBef>
+              <a:buNone/>
+              <a:defRPr sz="1350" b="0">
+                <a:solidFill>
+                  <a:srgbClr val="182232"/>
+                </a:solidFill>
+                <a:latin typeface="Space Grotesk"/>
+                <a:ea typeface="Space Grotesk"/>
+                <a:cs typeface="Space Grotesk"/>
+              </a:defRPr>
+            </a:lvl1pPr>
+          </a:lstStyle>
+          <a:p>
+            <a:r>
+              <a:rPr lang="en-US"/>
+              <a:t>Devcon 8 · Builder Enablement &amp; BuidlGuidl</a:t>
+            </a:r>
+          </a:p>
+        </p:txBody>
+      </p:sp>
+      <p:sp>
+        <p:nvSpPr>
+          <p:cNvPr id="139" name="Thanks"/>
+          <p:cNvSpPr>
+            <a:spLocks noGrp="1"/>
+          </p:cNvSpPr>
+          <p:nvPr>
+            <p:ph type="title"/>
+          </p:nvPr>
+        </p:nvSpPr>
+        <p:spPr>
+          <a:xfrm>
+            <a:off x="571500" y="1333500"/>
+            <a:ext cx="4000500" cy="523875"/>
+          </a:xfrm>
+          <a:prstGeom prst="rect">
+            <a:avLst/>
+          </a:prstGeom>
+        </p:spPr>
+        <p:txBody>
+          <a:bodyPr wrap="square" lIns="0" tIns="0" rIns="0" bIns="0" anchor="t">
+            <a:noAutofit/>
+          </a:bodyPr>
+          <a:lstStyle>
+            <a:lvl1pPr marL="0" indent="0" algn="l">
+              <a:lnSpc>
+                <a:spcPts val="3788"/>
+              </a:lnSpc>
+              <a:spcBef>
+                <a:spcPts val="0"/>
+              </a:spcBef>
+              <a:buNone/>
+              <a:defRPr sz="3600" b="1">
+                <a:solidFill>
+                  <a:srgbClr val="182232"/>
+                </a:solidFill>
+                <a:latin typeface="Space Grotesk"/>
+                <a:ea typeface="Space Grotesk"/>
+                <a:cs typeface="Space Grotesk"/>
+              </a:defRPr>
+            </a:lvl1pPr>
+          </a:lstStyle>
+          <a:p>
+            <a:r>
+              <a:rPr lang="en-US"/>
+              <a:t>Thanks</a:t>
+            </a:r>
+          </a:p>
+        </p:txBody>
+      </p:sp>
+      <p:sp>
+        <p:nvSpPr>
+          <p:cNvPr id="140" name="Speaker name"/>
+          <p:cNvSpPr>
+            <a:spLocks noGrp="1"/>
+          </p:cNvSpPr>
+          <p:nvPr>
+            <p:ph type="body" idx="1"/>
+          </p:nvPr>
+        </p:nvSpPr>
+        <p:spPr>
+          <a:xfrm>
+            <a:off x="571500" y="2095500"/>
+            <a:ext cx="4191000" cy="295275"/>
+          </a:xfrm>
+          <a:prstGeom prst="rect">
+            <a:avLst/>
+          </a:prstGeom>
+        </p:spPr>
+        <p:txBody>
+          <a:bodyPr wrap="square" lIns="0" tIns="0" rIns="0" bIns="0" anchor="t">
+            <a:noAutofit/>
+          </a:bodyPr>
+          <a:lstStyle>
+            <a:lvl1pPr marL="0" indent="0" algn="l">
+              <a:lnSpc>
+                <a:spcPts val="2325"/>
+              </a:lnSpc>
+              <a:spcBef>
+                <a:spcPts val="0"/>
+              </a:spcBef>
+              <a:buNone/>
+              <a:defRPr sz="1800" b="1">
+                <a:solidFill>
+                  <a:srgbClr val="182232"/>
+                </a:solidFill>
+                <a:latin typeface="Space Grotesk"/>
+                <a:ea typeface="Space Grotesk"/>
+                <a:cs typeface="Space Grotesk"/>
+              </a:defRPr>
+            </a:lvl1pPr>
+          </a:lstStyle>
+          <a:p>
+            <a:r>
+              <a:rPr lang="en-US"/>
+              <a:t>Speaker name</a:t>
+            </a:r>
+          </a:p>
+        </p:txBody>
+      </p:sp>
+      <p:sp>
+        <p:nvSpPr>
+          <p:cNvPr id="141" name="Handles"/>
+          <p:cNvSpPr>
+            <a:spLocks noGrp="1"/>
+          </p:cNvSpPr>
+          <p:nvPr>
+            <p:ph type="body" idx="2"/>
+          </p:nvPr>
+        </p:nvSpPr>
+        <p:spPr>
+          <a:xfrm>
+            <a:off x="571500" y="2400300"/>
+            <a:ext cx="4191000" cy="295275"/>
+          </a:xfrm>
+          <a:prstGeom prst="rect">
+            <a:avLst/>
+          </a:prstGeom>
+        </p:spPr>
+        <p:txBody>
+          <a:bodyPr wrap="square" lIns="0" tIns="0" rIns="0" bIns="0" anchor="t">
+            <a:noAutofit/>
+          </a:bodyPr>
+          <a:lstStyle>
+            <a:lvl1pPr marL="0" indent="0" algn="l">
+              <a:lnSpc>
+                <a:spcPts val="2325"/>
               </a:lnSpc>
               <a:spcBef>
                 <a:spcPts val="0"/>
@@ -427,25 +577,25 @@
           <a:p>
             <a:r>
               <a:rPr lang="en-US"/>
-              <a:t>Devcon 8 · Builder Enablement &amp; BuidlGuidl</a:t>
-            </a:r>
-          </a:p>
-        </p:txBody>
-      </p:sp>
-      <p:sp>
-        <p:nvSpPr>
-          <p:cNvPr id="139" name="Thanks"/>
-          <p:cNvSpPr>
-            <a:spLocks noGrp="1"/>
-          </p:cNvSpPr>
-          <p:nvPr>
-            <p:ph type="title"/>
-          </p:nvPr>
-        </p:nvSpPr>
-        <p:spPr>
-          <a:xfrm>
-            <a:off x="762000" y="1778000"/>
-            <a:ext cx="5334000" cy="698500"/>
+              <a:t>@handle on X and GitHub</a:t>
+            </a:r>
+          </a:p>
+        </p:txBody>
+      </p:sp>
+      <p:sp>
+        <p:nvSpPr>
+          <p:cNvPr id="142" name="Link"/>
+          <p:cNvSpPr>
+            <a:spLocks noGrp="1"/>
+          </p:cNvSpPr>
+          <p:nvPr>
+            <p:ph type="body" idx="3"/>
+          </p:nvPr>
+        </p:nvSpPr>
+        <p:spPr>
+          <a:xfrm>
+            <a:off x="571500" y="2781300"/>
+            <a:ext cx="4191000" cy="295275"/>
           </a:xfrm>
           <a:prstGeom prst="rect">
             <a:avLst/>
@@ -458,163 +608,13 @@
           <a:lstStyle>
             <a:lvl1pPr marL="0" indent="0" algn="l">
               <a:lnSpc>
-                <a:spcPts val="5050"/>
+                <a:spcPts val="2325"/>
               </a:lnSpc>
               <a:spcBef>
                 <a:spcPts val="0"/>
               </a:spcBef>
               <a:buNone/>
-              <a:defRPr sz="4800" b="0">
-                <a:solidFill>
-                  <a:srgbClr val="182232"/>
-                </a:solidFill>
-                <a:latin typeface="PP Neue Machina Inktrap Smbold"/>
-                <a:ea typeface="PP Neue Machina Inktrap Smbold"/>
-                <a:cs typeface="PP Neue Machina Inktrap Smbold"/>
-              </a:defRPr>
-            </a:lvl1pPr>
-          </a:lstStyle>
-          <a:p>
-            <a:r>
-              <a:rPr lang="en-US"/>
-              <a:t>Thanks</a:t>
-            </a:r>
-          </a:p>
-        </p:txBody>
-      </p:sp>
-      <p:sp>
-        <p:nvSpPr>
-          <p:cNvPr id="140" name="Speaker name"/>
-          <p:cNvSpPr>
-            <a:spLocks noGrp="1"/>
-          </p:cNvSpPr>
-          <p:nvPr>
-            <p:ph type="body" idx="1"/>
-          </p:nvPr>
-        </p:nvSpPr>
-        <p:spPr>
-          <a:xfrm>
-            <a:off x="762000" y="2794000"/>
-            <a:ext cx="5588000" cy="393700"/>
-          </a:xfrm>
-          <a:prstGeom prst="rect">
-            <a:avLst/>
-          </a:prstGeom>
-        </p:spPr>
-        <p:txBody>
-          <a:bodyPr wrap="square" lIns="0" tIns="0" rIns="0" bIns="0" anchor="t">
-            <a:noAutofit/>
-          </a:bodyPr>
-          <a:lstStyle>
-            <a:lvl1pPr marL="0" indent="0" algn="l">
-              <a:lnSpc>
-                <a:spcPts val="3100"/>
-              </a:lnSpc>
-              <a:spcBef>
-                <a:spcPts val="0"/>
-              </a:spcBef>
-              <a:buNone/>
-              <a:defRPr sz="2400" b="1">
-                <a:solidFill>
-                  <a:srgbClr val="182232"/>
-                </a:solidFill>
-                <a:latin typeface="Space Grotesk"/>
-                <a:ea typeface="Space Grotesk"/>
-                <a:cs typeface="Space Grotesk"/>
-              </a:defRPr>
-            </a:lvl1pPr>
-          </a:lstStyle>
-          <a:p>
-            <a:r>
-              <a:rPr lang="en-US"/>
-              <a:t>Speaker name</a:t>
-            </a:r>
-          </a:p>
-        </p:txBody>
-      </p:sp>
-      <p:sp>
-        <p:nvSpPr>
-          <p:cNvPr id="141" name="Handles"/>
-          <p:cNvSpPr>
-            <a:spLocks noGrp="1"/>
-          </p:cNvSpPr>
-          <p:nvPr>
-            <p:ph type="body" idx="2"/>
-          </p:nvPr>
-        </p:nvSpPr>
-        <p:spPr>
-          <a:xfrm>
-            <a:off x="762000" y="3200400"/>
-            <a:ext cx="5588000" cy="393700"/>
-          </a:xfrm>
-          <a:prstGeom prst="rect">
-            <a:avLst/>
-          </a:prstGeom>
-        </p:spPr>
-        <p:txBody>
-          <a:bodyPr wrap="square" lIns="0" tIns="0" rIns="0" bIns="0" anchor="t">
-            <a:noAutofit/>
-          </a:bodyPr>
-          <a:lstStyle>
-            <a:lvl1pPr marL="0" indent="0" algn="l">
-              <a:lnSpc>
-                <a:spcPts val="3100"/>
-              </a:lnSpc>
-              <a:spcBef>
-                <a:spcPts val="0"/>
-              </a:spcBef>
-              <a:buNone/>
-              <a:defRPr sz="2400" b="0">
-                <a:solidFill>
-                  <a:srgbClr val="182232"/>
-                </a:solidFill>
-                <a:latin typeface="Space Grotesk"/>
-                <a:ea typeface="Space Grotesk"/>
-                <a:cs typeface="Space Grotesk"/>
-              </a:defRPr>
-            </a:lvl1pPr>
-          </a:lstStyle>
-          <a:p>
-            <a:r>
-              <a:rPr lang="en-US"/>
-              <a:t>@handle on X and GitHub</a:t>
-            </a:r>
-          </a:p>
-        </p:txBody>
-      </p:sp>
-      <p:sp>
-        <p:nvSpPr>
-          <p:cNvPr id="142" name="Link"/>
-          <p:cNvSpPr>
-            <a:spLocks noGrp="1"/>
-          </p:cNvSpPr>
-          <p:nvPr>
-            <p:ph type="body" idx="3"/>
-          </p:nvPr>
-        </p:nvSpPr>
-        <p:spPr>
-          <a:xfrm>
-            <a:off x="762000" y="3708400"/>
-            <a:ext cx="5588000" cy="393700"/>
-          </a:xfrm>
-          <a:prstGeom prst="rect">
-            <a:avLst/>
-          </a:prstGeom>
-        </p:spPr>
-        <p:txBody>
-          <a:bodyPr wrap="square" lIns="0" tIns="0" rIns="0" bIns="0" anchor="t">
-            <a:noAutofit/>
-          </a:bodyPr>
-          <a:lstStyle>
-            <a:lvl1pPr marL="0" indent="0" algn="l">
-              <a:lnSpc>
-                <a:spcPts val="3100"/>
-              </a:lnSpc>
-              <a:spcBef>
-                <a:spcPts val="0"/>
-              </a:spcBef>
-              <a:buNone/>
-              <a:defRPr sz="2400" b="0">
+              <a:defRPr sz="1800" b="0">
                 <a:solidFill>
                   <a:srgbClr val="182232"/>
                 </a:solidFill>
@@ -682,8 +682,8 @@
         </p:nvSpPr>
         <p:spPr>
           <a:xfrm>
-            <a:off x="762000" y="1270000"/>
-            <a:ext cx="6350000" cy="298450"/>
+            <a:off x="571500" y="952500"/>
+            <a:ext cx="4762500" cy="223838"/>
           </a:xfrm>
           <a:prstGeom prst="rect">
             <a:avLst/>
@@ -697,163 +697,163 @@
           <a:lstStyle>
             <a:lvl1pPr marL="0" indent="0" algn="l">
               <a:lnSpc>
-                <a:spcPts val="2350"/>
+                <a:spcPts val="1762"/>
+              </a:lnSpc>
+              <a:spcBef>
+                <a:spcPts val="0"/>
+              </a:spcBef>
+              <a:buNone/>
+              <a:defRPr sz="1350" b="0">
+                <a:solidFill>
+                  <a:srgbClr val="182232"/>
+                </a:solidFill>
+                <a:latin typeface="Space Grotesk"/>
+                <a:ea typeface="Space Grotesk"/>
+                <a:cs typeface="Space Grotesk"/>
+              </a:defRPr>
+            </a:lvl1pPr>
+          </a:lstStyle>
+          <a:p>
+            <a:r>
+              <a:rPr lang="en-US"/>
+              <a:t>Up next</a:t>
+            </a:r>
+          </a:p>
+        </p:txBody>
+      </p:sp>
+      <p:sp>
+        <p:nvSpPr>
+          <p:cNvPr id="144" name="Talk title"/>
+          <p:cNvSpPr>
+            <a:spLocks noGrp="1"/>
+          </p:cNvSpPr>
+          <p:nvPr>
+            <p:ph type="title"/>
+          </p:nvPr>
+        </p:nvSpPr>
+        <p:spPr>
+          <a:xfrm>
+            <a:off x="571500" y="1333500"/>
+            <a:ext cx="4000500" cy="1476375"/>
+          </a:xfrm>
+          <a:prstGeom prst="rect">
+            <a:avLst/>
+          </a:prstGeom>
+        </p:spPr>
+        <p:txBody>
+          <a:bodyPr wrap="square" lIns="0" tIns="0" rIns="0" bIns="0" anchor="t">
+            <a:noAutofit/>
+          </a:bodyPr>
+          <a:lstStyle>
+            <a:lvl1pPr marL="0" indent="0" algn="l">
+              <a:lnSpc>
+                <a:spcPts val="3788"/>
+              </a:lnSpc>
+              <a:spcBef>
+                <a:spcPts val="0"/>
+              </a:spcBef>
+              <a:buNone/>
+              <a:defRPr sz="3600" b="1">
+                <a:solidFill>
+                  <a:srgbClr val="182232"/>
+                </a:solidFill>
+                <a:latin typeface="Space Grotesk"/>
+                <a:ea typeface="Space Grotesk"/>
+                <a:cs typeface="Space Grotesk"/>
+              </a:defRPr>
+            </a:lvl1pPr>
+          </a:lstStyle>
+          <a:p>
+            <a:r>
+              <a:rPr lang="en-US"/>
+              <a:t>Talk title</a:t>
+            </a:r>
+          </a:p>
+        </p:txBody>
+      </p:sp>
+      <p:sp>
+        <p:nvSpPr>
+          <p:cNvPr id="145" name="Speaker"/>
+          <p:cNvSpPr>
+            <a:spLocks noGrp="1"/>
+          </p:cNvSpPr>
+          <p:nvPr>
+            <p:ph type="body" idx="1"/>
+          </p:nvPr>
+        </p:nvSpPr>
+        <p:spPr>
+          <a:xfrm>
+            <a:off x="571500" y="2971800"/>
+            <a:ext cx="4286250" cy="295275"/>
+          </a:xfrm>
+          <a:prstGeom prst="rect">
+            <a:avLst/>
+          </a:prstGeom>
+        </p:spPr>
+        <p:txBody>
+          <a:bodyPr wrap="square" lIns="0" tIns="0" rIns="0" bIns="0" anchor="t">
+            <a:noAutofit/>
+          </a:bodyPr>
+          <a:lstStyle>
+            <a:lvl1pPr marL="0" indent="0" algn="l">
+              <a:lnSpc>
+                <a:spcPts val="2325"/>
+              </a:lnSpc>
+              <a:spcBef>
+                <a:spcPts val="0"/>
+              </a:spcBef>
+              <a:buNone/>
+              <a:defRPr sz="1800" b="1">
+                <a:solidFill>
+                  <a:srgbClr val="182232"/>
+                </a:solidFill>
+                <a:latin typeface="Space Grotesk"/>
+                <a:ea typeface="Space Grotesk"/>
+                <a:cs typeface="Space Grotesk"/>
+              </a:defRPr>
+            </a:lvl1pPr>
+          </a:lstStyle>
+          <a:p>
+            <a:r>
+              <a:rPr lang="en-US"/>
+              <a:t>Speaker, affiliation</a:t>
+            </a:r>
+          </a:p>
+        </p:txBody>
+      </p:sp>
+      <p:sp>
+        <p:nvSpPr>
+          <p:cNvPr id="146" name="Time and room"/>
+          <p:cNvSpPr>
+            <a:spLocks noGrp="1"/>
+          </p:cNvSpPr>
+          <p:nvPr>
+            <p:ph type="body" idx="2"/>
+          </p:nvPr>
+        </p:nvSpPr>
+        <p:spPr>
+          <a:xfrm>
+            <a:off x="571500" y="3276600"/>
+            <a:ext cx="4286250" cy="295275"/>
+          </a:xfrm>
+          <a:prstGeom prst="rect">
+            <a:avLst/>
+          </a:prstGeom>
+        </p:spPr>
+        <p:txBody>
+          <a:bodyPr wrap="square" lIns="0" tIns="0" rIns="0" bIns="0" anchor="t">
+            <a:noAutofit/>
+          </a:bodyPr>
+          <a:lstStyle>
+            <a:lvl1pPr marL="0" indent="0" algn="l">
+              <a:lnSpc>
+                <a:spcPts val="2325"/>
               </a:lnSpc>
               <a:spcBef>
                 <a:spcPts val="0"/>
               </a:spcBef>
               <a:buNone/>
               <a:defRPr sz="1800" b="0">
-                <a:solidFill>
-                  <a:srgbClr val="182232"/>
-                </a:solidFill>
-                <a:latin typeface="Space Grotesk"/>
-                <a:ea typeface="Space Grotesk"/>
-                <a:cs typeface="Space Grotesk"/>
-              </a:defRPr>
-            </a:lvl1pPr>
-          </a:lstStyle>
-          <a:p>
-            <a:r>
-              <a:rPr lang="en-US"/>
-              <a:t>Up next</a:t>
-            </a:r>
-          </a:p>
-        </p:txBody>
-      </p:sp>
-      <p:sp>
-        <p:nvSpPr>
-          <p:cNvPr id="144" name="Talk title"/>
-          <p:cNvSpPr>
-            <a:spLocks noGrp="1"/>
-          </p:cNvSpPr>
-          <p:nvPr>
-            <p:ph type="title"/>
-          </p:nvPr>
-        </p:nvSpPr>
-        <p:spPr>
-          <a:xfrm>
-            <a:off x="762000" y="1778000"/>
-            <a:ext cx="5334000" cy="1968500"/>
-          </a:xfrm>
-          <a:prstGeom prst="rect">
-            <a:avLst/>
-          </a:prstGeom>
-        </p:spPr>
-        <p:txBody>
-          <a:bodyPr wrap="square" lIns="0" tIns="0" rIns="0" bIns="0" anchor="t">
-            <a:noAutofit/>
-          </a:bodyPr>
-          <a:lstStyle>
-            <a:lvl1pPr marL="0" indent="0" algn="l">
-              <a:lnSpc>
-                <a:spcPts val="5050"/>
-              </a:lnSpc>
-              <a:spcBef>
-                <a:spcPts val="0"/>
-              </a:spcBef>
-              <a:buNone/>
-              <a:defRPr sz="4800" b="0">
-                <a:solidFill>
-                  <a:srgbClr val="182232"/>
-                </a:solidFill>
-                <a:latin typeface="PP Neue Machina Inktrap Smbold"/>
-                <a:ea typeface="PP Neue Machina Inktrap Smbold"/>
-                <a:cs typeface="PP Neue Machina Inktrap Smbold"/>
-              </a:defRPr>
-            </a:lvl1pPr>
-          </a:lstStyle>
-          <a:p>
-            <a:r>
-              <a:rPr lang="en-US"/>
-              <a:t>Talk title</a:t>
-            </a:r>
-          </a:p>
-        </p:txBody>
-      </p:sp>
-      <p:sp>
-        <p:nvSpPr>
-          <p:cNvPr id="145" name="Speaker"/>
-          <p:cNvSpPr>
-            <a:spLocks noGrp="1"/>
-          </p:cNvSpPr>
-          <p:nvPr>
-            <p:ph type="body" idx="1"/>
-          </p:nvPr>
-        </p:nvSpPr>
-        <p:spPr>
-          <a:xfrm>
-            <a:off x="762000" y="3962400"/>
-            <a:ext cx="5715000" cy="393700"/>
-          </a:xfrm>
-          <a:prstGeom prst="rect">
-            <a:avLst/>
-          </a:prstGeom>
-        </p:spPr>
-        <p:txBody>
-          <a:bodyPr wrap="square" lIns="0" tIns="0" rIns="0" bIns="0" anchor="t">
-            <a:noAutofit/>
-          </a:bodyPr>
-          <a:lstStyle>
-            <a:lvl1pPr marL="0" indent="0" algn="l">
-              <a:lnSpc>
-                <a:spcPts val="3100"/>
-              </a:lnSpc>
-              <a:spcBef>
-                <a:spcPts val="0"/>
-              </a:spcBef>
-              <a:buNone/>
-              <a:defRPr sz="2400" b="1">
-                <a:solidFill>
-                  <a:srgbClr val="182232"/>
-                </a:solidFill>
-                <a:latin typeface="Space Grotesk"/>
-                <a:ea typeface="Space Grotesk"/>
-                <a:cs typeface="Space Grotesk"/>
-              </a:defRPr>
-            </a:lvl1pPr>
-          </a:lstStyle>
-          <a:p>
-            <a:r>
-              <a:rPr lang="en-US"/>
-              <a:t>Speaker, affiliation</a:t>
-            </a:r>
-          </a:p>
-        </p:txBody>
-      </p:sp>
-      <p:sp>
-        <p:nvSpPr>
-          <p:cNvPr id="146" name="Time and room"/>
-          <p:cNvSpPr>
-            <a:spLocks noGrp="1"/>
-          </p:cNvSpPr>
-          <p:nvPr>
-            <p:ph type="body" idx="2"/>
-          </p:nvPr>
-        </p:nvSpPr>
-        <p:spPr>
-          <a:xfrm>
-            <a:off x="762000" y="4368800"/>
-            <a:ext cx="5715000" cy="393700"/>
-          </a:xfrm>
-          <a:prstGeom prst="rect">
-            <a:avLst/>
-          </a:prstGeom>
-        </p:spPr>
-        <p:txBody>
-          <a:bodyPr wrap="square" lIns="0" tIns="0" rIns="0" bIns="0" anchor="t">
-            <a:noAutofit/>
-          </a:bodyPr>
-          <a:lstStyle>
-            <a:lvl1pPr marL="0" indent="0" algn="l">
-              <a:lnSpc>
-                <a:spcPts val="3100"/>
-              </a:lnSpc>
-              <a:spcBef>
-                <a:spcPts val="0"/>
-              </a:spcBef>
-              <a:buNone/>
-              <a:defRPr sz="2400" b="0">
                 <a:solidFill>
                   <a:srgbClr val="182232"/>
                 </a:solidFill>
@@ -925,8 +925,8 @@
         </p:nvSpPr>
         <p:spPr>
           <a:xfrm>
-            <a:off x="762000" y="1905000"/>
-            <a:ext cx="10668000" cy="2540000"/>
+            <a:off x="571500" y="1428750"/>
+            <a:ext cx="8001000" cy="1905000"/>
           </a:xfrm>
           <a:prstGeom prst="rect">
             <a:avLst/>
@@ -939,19 +939,19 @@
           <a:lstStyle>
             <a:lvl1pPr marL="0" indent="0" algn="l">
               <a:lnSpc>
-                <a:spcPts val="6300"/>
+                <a:spcPts val="4725"/>
               </a:lnSpc>
               <a:spcBef>
                 <a:spcPts val="0"/>
               </a:spcBef>
               <a:buNone/>
-              <a:defRPr sz="6000" b="0">
+              <a:defRPr sz="4500" b="1">
                 <a:solidFill>
                   <a:srgbClr val="182232"/>
                 </a:solidFill>
-                <a:latin typeface="PP Neue Machina Inktrap Smbold"/>
-                <a:ea typeface="PP Neue Machina Inktrap Smbold"/>
-                <a:cs typeface="PP Neue Machina Inktrap Smbold"/>
+                <a:latin typeface="Space Grotesk"/>
+                <a:ea typeface="Space Grotesk"/>
+                <a:cs typeface="Space Grotesk"/>
               </a:defRPr>
             </a:lvl1pPr>
           </a:lstStyle>
@@ -975,8 +975,8 @@
         </p:nvSpPr>
         <p:spPr>
           <a:xfrm>
-            <a:off x="762000" y="4826000"/>
-            <a:ext cx="10668000" cy="393700"/>
+            <a:off x="571500" y="3619500"/>
+            <a:ext cx="8001000" cy="295275"/>
           </a:xfrm>
           <a:prstGeom prst="rect">
             <a:avLst/>
@@ -989,13 +989,13 @@
           <a:lstStyle>
             <a:lvl1pPr marL="0" indent="0" algn="l">
               <a:lnSpc>
-                <a:spcPts val="3100"/>
+                <a:spcPts val="2325"/>
               </a:lnSpc>
               <a:spcBef>
                 <a:spcPts val="0"/>
               </a:spcBef>
               <a:buNone/>
-              <a:defRPr sz="2400" b="0">
+              <a:defRPr sz="1800" b="0">
                 <a:solidFill>
                   <a:srgbClr val="182232"/>
                 </a:solidFill>
@@ -1067,8 +1067,8 @@
         </p:nvSpPr>
         <p:spPr>
           <a:xfrm>
-            <a:off x="762000" y="609600"/>
-            <a:ext cx="10668000" cy="1117600"/>
+            <a:off x="571500" y="457200"/>
+            <a:ext cx="8001000" cy="838200"/>
           </a:xfrm>
           <a:prstGeom prst="rect">
             <a:avLst/>
@@ -1081,19 +1081,19 @@
           <a:lstStyle>
             <a:lvl1pPr marL="0" indent="0" algn="l">
               <a:lnSpc>
-                <a:spcPts val="4400"/>
+                <a:spcPts val="3300"/>
               </a:lnSpc>
               <a:spcBef>
                 <a:spcPts val="0"/>
               </a:spcBef>
               <a:buNone/>
-              <a:defRPr sz="4000" b="0">
+              <a:defRPr sz="3000" b="1">
                 <a:solidFill>
                   <a:srgbClr val="182232"/>
                 </a:solidFill>
-                <a:latin typeface="PP Neue Machina Inktrap Smbold"/>
-                <a:ea typeface="PP Neue Machina Inktrap Smbold"/>
-                <a:cs typeface="PP Neue Machina Inktrap Smbold"/>
+                <a:latin typeface="Space Grotesk"/>
+                <a:ea typeface="Space Grotesk"/>
+                <a:cs typeface="Space Grotesk"/>
               </a:defRPr>
             </a:lvl1pPr>
           </a:lstStyle>
@@ -1117,8 +1117,8 @@
         </p:nvSpPr>
         <p:spPr>
           <a:xfrm>
-            <a:off x="762000" y="2032000"/>
-            <a:ext cx="10668000" cy="4216400"/>
+            <a:off x="571500" y="1524000"/>
+            <a:ext cx="8001000" cy="3162300"/>
           </a:xfrm>
           <a:prstGeom prst="rect">
             <a:avLst/>
@@ -1129,12 +1129,12 @@
             <a:noAutofit/>
           </a:bodyPr>
           <a:lstStyle>
-            <a:lvl1pPr marL="406400" indent="-406400" algn="l">
+            <a:lvl1pPr marL="304800" indent="-304800" algn="l">
               <a:lnSpc>
-                <a:spcPts val="3100"/>
+                <a:spcPts val="2325"/>
               </a:lnSpc>
               <a:spcBef>
-                <a:spcPts val="1600"/>
+                <a:spcPts val="1200"/>
               </a:spcBef>
               <a:buClr>
                 <a:srgbClr val="808CFF"/>
@@ -1142,7 +1142,7 @@
               <a:buSzPct val="80000"/>
               <a:buFont typeface="Arial"/>
               <a:buChar char="●"/>
-              <a:defRPr sz="2400" b="0">
+              <a:defRPr sz="1800" b="0">
                 <a:solidFill>
                   <a:srgbClr val="182232"/>
                 </a:solidFill>
@@ -1214,8 +1214,8 @@
         </p:nvSpPr>
         <p:spPr>
           <a:xfrm>
-            <a:off x="762000" y="609600"/>
-            <a:ext cx="10668000" cy="609600"/>
+            <a:off x="571500" y="457200"/>
+            <a:ext cx="8001000" cy="457200"/>
           </a:xfrm>
           <a:prstGeom prst="rect">
             <a:avLst/>
@@ -1228,19 +1228,19 @@
           <a:lstStyle>
             <a:lvl1pPr marL="0" indent="0" algn="l">
               <a:lnSpc>
-                <a:spcPts val="4400"/>
+                <a:spcPts val="3300"/>
               </a:lnSpc>
               <a:spcBef>
                 <a:spcPts val="0"/>
               </a:spcBef>
               <a:buNone/>
-              <a:defRPr sz="4000" b="0">
+              <a:defRPr sz="3000" b="1">
                 <a:solidFill>
                   <a:srgbClr val="182232"/>
                 </a:solidFill>
-                <a:latin typeface="PP Neue Machina Inktrap Smbold"/>
-                <a:ea typeface="PP Neue Machina Inktrap Smbold"/>
-                <a:cs typeface="PP Neue Machina Inktrap Smbold"/>
+                <a:latin typeface="Space Grotesk"/>
+                <a:ea typeface="Space Grotesk"/>
+                <a:cs typeface="Space Grotesk"/>
               </a:defRPr>
             </a:lvl1pPr>
           </a:lstStyle>
@@ -1260,8 +1260,8 @@
         </p:nvSpPr>
         <p:spPr>
           <a:xfrm>
-            <a:off x="762000" y="1473200"/>
-            <a:ext cx="10668000" cy="4775200"/>
+            <a:off x="571500" y="1104900"/>
+            <a:ext cx="8001000" cy="3581400"/>
           </a:xfrm>
           <a:prstGeom prst="roundRect">
             <a:avLst>
@@ -1293,8 +1293,8 @@
         </p:nvSpPr>
         <p:spPr>
           <a:xfrm>
-            <a:off x="1016000" y="1727200"/>
-            <a:ext cx="10160000" cy="4267200"/>
+            <a:off x="762000" y="1295400"/>
+            <a:ext cx="7620000" cy="3200400"/>
           </a:xfrm>
           <a:prstGeom prst="rect">
             <a:avLst/>
@@ -1355,8 +1355,8 @@
         </p:nvSpPr>
         <p:spPr>
           <a:xfrm>
-            <a:off x="762000" y="609600"/>
-            <a:ext cx="10668000" cy="609600"/>
+            <a:off x="571500" y="457200"/>
+            <a:ext cx="8001000" cy="457200"/>
           </a:xfrm>
           <a:prstGeom prst="rect">
             <a:avLst/>
@@ -1369,19 +1369,19 @@
           <a:lstStyle>
             <a:lvl1pPr marL="0" indent="0" algn="l">
               <a:lnSpc>
-                <a:spcPts val="4400"/>
+                <a:spcPts val="3300"/>
               </a:lnSpc>
               <a:spcBef>
                 <a:spcPts val="0"/>
               </a:spcBef>
               <a:buNone/>
-              <a:defRPr sz="4000" b="0">
+              <a:defRPr sz="3000" b="1">
                 <a:solidFill>
                   <a:srgbClr val="182232"/>
                 </a:solidFill>
-                <a:latin typeface="PP Neue Machina Inktrap Smbold"/>
-                <a:ea typeface="PP Neue Machina Inktrap Smbold"/>
-                <a:cs typeface="PP Neue Machina Inktrap Smbold"/>
+                <a:latin typeface="Space Grotesk"/>
+                <a:ea typeface="Space Grotesk"/>
+                <a:cs typeface="Space Grotesk"/>
               </a:defRPr>
             </a:lvl1pPr>
           </a:lstStyle>
@@ -1401,8 +1401,8 @@
         </p:nvSpPr>
         <p:spPr>
           <a:xfrm>
-            <a:off x="762000" y="1651000"/>
-            <a:ext cx="3352800" cy="3302000"/>
+            <a:off x="571500" y="1238250"/>
+            <a:ext cx="2514600" cy="2476500"/>
           </a:xfrm>
           <a:prstGeom prst="roundRect">
             <a:avLst>
@@ -1430,8 +1430,8 @@
         </p:nvSpPr>
         <p:spPr>
           <a:xfrm>
-            <a:off x="1066800" y="1955800"/>
-            <a:ext cx="609600" cy="406400"/>
+            <a:off x="800100" y="1466850"/>
+            <a:ext cx="457200" cy="304800"/>
           </a:xfrm>
           <a:prstGeom prst="roundRect">
             <a:avLst>
@@ -1459,8 +1459,8 @@
         </p:nvSpPr>
         <p:spPr>
           <a:xfrm>
-            <a:off x="1066800" y="2044700"/>
-            <a:ext cx="609600" cy="254000"/>
+            <a:off x="800100" y="1533525"/>
+            <a:ext cx="457200" cy="190500"/>
           </a:xfrm>
           <a:prstGeom prst="rect">
             <a:avLst/>
@@ -1474,7 +1474,107 @@
           <a:lstStyle>
             <a:lvl1pPr marL="0" indent="0" algn="ctr">
               <a:lnSpc>
-                <a:spcPts val="2350"/>
+                <a:spcPts val="1762"/>
+              </a:lnSpc>
+              <a:spcBef>
+                <a:spcPts val="0"/>
+              </a:spcBef>
+              <a:buNone/>
+              <a:defRPr sz="1350" b="0">
+                <a:solidFill>
+                  <a:srgbClr val="182232"/>
+                </a:solidFill>
+                <a:latin typeface="Space Grotesk"/>
+                <a:ea typeface="Space Grotesk"/>
+                <a:cs typeface="Space Grotesk"/>
+              </a:defRPr>
+            </a:lvl1pPr>
+          </a:lstStyle>
+          <a:p>
+            <a:r>
+              <a:rPr lang="en-US"/>
+              <a:t>01</a:t>
+            </a:r>
+          </a:p>
+        </p:txBody>
+      </p:sp>
+      <p:sp>
+        <p:nvSpPr>
+          <p:cNvPr id="116" name="Column 1 title"/>
+          <p:cNvSpPr>
+            <a:spLocks noGrp="1"/>
+          </p:cNvSpPr>
+          <p:nvPr>
+            <p:ph type="body" idx="1"/>
+          </p:nvPr>
+        </p:nvSpPr>
+        <p:spPr>
+          <a:xfrm>
+            <a:off x="800100" y="1924050"/>
+            <a:ext cx="2057400" cy="571500"/>
+          </a:xfrm>
+          <a:prstGeom prst="rect">
+            <a:avLst/>
+          </a:prstGeom>
+        </p:spPr>
+        <p:txBody>
+          <a:bodyPr wrap="square" lIns="0" tIns="0" rIns="0" bIns="0" anchor="t">
+            <a:noAutofit/>
+          </a:bodyPr>
+          <a:lstStyle>
+            <a:lvl1pPr marL="0" indent="0" algn="l">
+              <a:lnSpc>
+                <a:spcPts val="2325"/>
+              </a:lnSpc>
+              <a:spcBef>
+                <a:spcPts val="0"/>
+              </a:spcBef>
+              <a:buNone/>
+              <a:defRPr sz="1800" b="1">
+                <a:solidFill>
+                  <a:srgbClr val="182232"/>
+                </a:solidFill>
+                <a:latin typeface="Space Grotesk"/>
+                <a:ea typeface="Space Grotesk"/>
+                <a:cs typeface="Space Grotesk"/>
+              </a:defRPr>
+            </a:lvl1pPr>
+          </a:lstStyle>
+          <a:p>
+            <a:r>
+              <a:rPr lang="en-US"/>
+              <a:t>Column title</a:t>
+            </a:r>
+          </a:p>
+        </p:txBody>
+      </p:sp>
+      <p:sp>
+        <p:nvSpPr>
+          <p:cNvPr id="117" name="Column 1 text"/>
+          <p:cNvSpPr>
+            <a:spLocks noGrp="1"/>
+          </p:cNvSpPr>
+          <p:nvPr>
+            <p:ph type="body" idx="2"/>
+          </p:nvPr>
+        </p:nvSpPr>
+        <p:spPr>
+          <a:xfrm>
+            <a:off x="800100" y="2590800"/>
+            <a:ext cx="2057400" cy="952500"/>
+          </a:xfrm>
+          <a:prstGeom prst="rect">
+            <a:avLst/>
+          </a:prstGeom>
+        </p:spPr>
+        <p:txBody>
+          <a:bodyPr wrap="square" lIns="0" tIns="0" rIns="0" bIns="0" anchor="t">
+            <a:noAutofit/>
+          </a:bodyPr>
+          <a:lstStyle>
+            <a:lvl1pPr marL="0" indent="0" algn="l">
+              <a:lnSpc>
+                <a:spcPts val="2325"/>
               </a:lnSpc>
               <a:spcBef>
                 <a:spcPts val="0"/>
@@ -1493,25 +1593,130 @@
           <a:p>
             <a:r>
               <a:rPr lang="en-US"/>
-              <a:t>01</a:t>
-            </a:r>
-          </a:p>
-        </p:txBody>
-      </p:sp>
-      <p:sp>
-        <p:nvSpPr>
-          <p:cNvPr id="116" name="Column 1 title"/>
-          <p:cNvSpPr>
-            <a:spLocks noGrp="1"/>
-          </p:cNvSpPr>
-          <p:nvPr>
-            <p:ph type="body" idx="1"/>
-          </p:nvPr>
-        </p:nvSpPr>
-        <p:spPr>
-          <a:xfrm>
-            <a:off x="1066800" y="2565400"/>
-            <a:ext cx="2743200" cy="762000"/>
+              <a:t>One or two short lines</a:t>
+            </a:r>
+          </a:p>
+        </p:txBody>
+      </p:sp>
+      <p:sp>
+        <p:nvSpPr>
+          <p:cNvPr id="118" name="Card 2"/>
+          <p:cNvSpPr/>
+          <p:nvPr/>
+        </p:nvSpPr>
+        <p:spPr>
+          <a:xfrm>
+            <a:off x="3314700" y="1238250"/>
+            <a:ext cx="2514600" cy="2476500"/>
+          </a:xfrm>
+          <a:prstGeom prst="roundRect">
+            <a:avLst>
+              <a:gd name="adj" fmla="val 3077"/>
+            </a:avLst>
+          </a:prstGeom>
+          <a:solidFill>
+            <a:srgbClr val="F4F4F4"/>
+          </a:solidFill>
+          <a:ln>
+            <a:noFill/>
+          </a:ln>
+        </p:spPr>
+        <p:txBody>
+          <a:bodyPr/>
+          <a:lstStyle/>
+          <a:p/>
+        </p:txBody>
+      </p:sp>
+      <p:sp>
+        <p:nvSpPr>
+          <p:cNvPr id="119" name="Pill 2"/>
+          <p:cNvSpPr/>
+          <p:nvPr/>
+        </p:nvSpPr>
+        <p:spPr>
+          <a:xfrm>
+            <a:off x="3543300" y="1466850"/>
+            <a:ext cx="457200" cy="304800"/>
+          </a:xfrm>
+          <a:prstGeom prst="roundRect">
+            <a:avLst>
+              <a:gd name="adj" fmla="val 25000"/>
+            </a:avLst>
+          </a:prstGeom>
+          <a:solidFill>
+            <a:srgbClr val="FF6E1D"/>
+          </a:solidFill>
+          <a:ln>
+            <a:noFill/>
+          </a:ln>
+        </p:spPr>
+        <p:txBody>
+          <a:bodyPr/>
+          <a:lstStyle/>
+          <a:p/>
+        </p:txBody>
+      </p:sp>
+      <p:sp>
+        <p:nvSpPr>
+          <p:cNvPr id="120" name="Pill number 2"/>
+          <p:cNvSpPr txBox="1"/>
+          <p:nvPr/>
+        </p:nvSpPr>
+        <p:spPr>
+          <a:xfrm>
+            <a:off x="3543300" y="1533525"/>
+            <a:ext cx="457200" cy="190500"/>
+          </a:xfrm>
+          <a:prstGeom prst="rect">
+            <a:avLst/>
+          </a:prstGeom>
+          <a:noFill/>
+        </p:spPr>
+        <p:txBody>
+          <a:bodyPr wrap="square" lIns="0" tIns="0" rIns="0" bIns="0" anchor="t">
+            <a:noAutofit/>
+          </a:bodyPr>
+          <a:lstStyle>
+            <a:lvl1pPr marL="0" indent="0" algn="ctr">
+              <a:lnSpc>
+                <a:spcPts val="1762"/>
+              </a:lnSpc>
+              <a:spcBef>
+                <a:spcPts val="0"/>
+              </a:spcBef>
+              <a:buNone/>
+              <a:defRPr sz="1350" b="0">
+                <a:solidFill>
+                  <a:srgbClr val="182232"/>
+                </a:solidFill>
+                <a:latin typeface="Space Grotesk"/>
+                <a:ea typeface="Space Grotesk"/>
+                <a:cs typeface="Space Grotesk"/>
+              </a:defRPr>
+            </a:lvl1pPr>
+          </a:lstStyle>
+          <a:p>
+            <a:r>
+              <a:rPr lang="en-US"/>
+              <a:t>02</a:t>
+            </a:r>
+          </a:p>
+        </p:txBody>
+      </p:sp>
+      <p:sp>
+        <p:nvSpPr>
+          <p:cNvPr id="121" name="Column 2 title"/>
+          <p:cNvSpPr>
+            <a:spLocks noGrp="1"/>
+          </p:cNvSpPr>
+          <p:nvPr>
+            <p:ph type="body" idx="3"/>
+          </p:nvPr>
+        </p:nvSpPr>
+        <p:spPr>
+          <a:xfrm>
+            <a:off x="3543300" y="1924050"/>
+            <a:ext cx="2057400" cy="571500"/>
           </a:xfrm>
           <a:prstGeom prst="rect">
             <a:avLst/>
@@ -1524,13 +1729,13 @@
           <a:lstStyle>
             <a:lvl1pPr marL="0" indent="0" algn="l">
               <a:lnSpc>
-                <a:spcPts val="3100"/>
+                <a:spcPts val="2325"/>
               </a:lnSpc>
               <a:spcBef>
                 <a:spcPts val="0"/>
               </a:spcBef>
               <a:buNone/>
-              <a:defRPr sz="2400" b="1">
+              <a:defRPr sz="1800" b="1">
                 <a:solidFill>
                   <a:srgbClr val="182232"/>
                 </a:solidFill>
@@ -1550,18 +1755,18 @@
       </p:sp>
       <p:sp>
         <p:nvSpPr>
-          <p:cNvPr id="117" name="Column 1 text"/>
-          <p:cNvSpPr>
-            <a:spLocks noGrp="1"/>
-          </p:cNvSpPr>
-          <p:nvPr>
-            <p:ph type="body" idx="2"/>
-          </p:nvPr>
-        </p:nvSpPr>
-        <p:spPr>
-          <a:xfrm>
-            <a:off x="1066800" y="3454400"/>
-            <a:ext cx="2743200" cy="1270000"/>
+          <p:cNvPr id="122" name="Column 2 text"/>
+          <p:cNvSpPr>
+            <a:spLocks noGrp="1"/>
+          </p:cNvSpPr>
+          <p:nvPr>
+            <p:ph type="body" idx="4"/>
+          </p:nvPr>
+        </p:nvSpPr>
+        <p:spPr>
+          <a:xfrm>
+            <a:off x="3543300" y="2590800"/>
+            <a:ext cx="2057400" cy="952500"/>
           </a:xfrm>
           <a:prstGeom prst="rect">
             <a:avLst/>
@@ -1574,13 +1779,13 @@
           <a:lstStyle>
             <a:lvl1pPr marL="0" indent="0" algn="l">
               <a:lnSpc>
-                <a:spcPts val="3100"/>
+                <a:spcPts val="2325"/>
               </a:lnSpc>
               <a:spcBef>
                 <a:spcPts val="0"/>
               </a:spcBef>
               <a:buNone/>
-              <a:defRPr sz="2400" b="0">
+              <a:defRPr sz="1800" b="0">
                 <a:solidFill>
                   <a:srgbClr val="182232"/>
                 </a:solidFill>
@@ -1600,14 +1805,14 @@
       </p:sp>
       <p:sp>
         <p:nvSpPr>
-          <p:cNvPr id="118" name="Card 2"/>
+          <p:cNvPr id="123" name="Card 3"/>
           <p:cNvSpPr/>
           <p:nvPr/>
         </p:nvSpPr>
         <p:spPr>
           <a:xfrm>
-            <a:off x="4419600" y="1651000"/>
-            <a:ext cx="3352800" cy="3302000"/>
+            <a:off x="6057900" y="1238250"/>
+            <a:ext cx="2514600" cy="2476500"/>
           </a:xfrm>
           <a:prstGeom prst="roundRect">
             <a:avLst>
@@ -1629,14 +1834,14 @@
       </p:sp>
       <p:sp>
         <p:nvSpPr>
-          <p:cNvPr id="119" name="Pill 2"/>
+          <p:cNvPr id="124" name="Pill 3"/>
           <p:cNvSpPr/>
           <p:nvPr/>
         </p:nvSpPr>
         <p:spPr>
           <a:xfrm>
-            <a:off x="4724400" y="1955800"/>
-            <a:ext cx="609600" cy="406400"/>
+            <a:off x="6286500" y="1466850"/>
+            <a:ext cx="457200" cy="304800"/>
           </a:xfrm>
           <a:prstGeom prst="roundRect">
             <a:avLst>
@@ -1644,7 +1849,7 @@
             </a:avLst>
           </a:prstGeom>
           <a:solidFill>
-            <a:srgbClr val="FF6E1D"/>
+            <a:srgbClr val="B5DC3A"/>
           </a:solidFill>
           <a:ln>
             <a:noFill/>
@@ -1658,14 +1863,14 @@
       </p:sp>
       <p:sp>
         <p:nvSpPr>
-          <p:cNvPr id="120" name="Pill number 2"/>
+          <p:cNvPr id="125" name="Pill number 3"/>
           <p:cNvSpPr txBox="1"/>
           <p:nvPr/>
         </p:nvSpPr>
         <p:spPr>
           <a:xfrm>
-            <a:off x="4724400" y="2044700"/>
-            <a:ext cx="609600" cy="254000"/>
+            <a:off x="6286500" y="1533525"/>
+            <a:ext cx="457200" cy="190500"/>
           </a:xfrm>
           <a:prstGeom prst="rect">
             <a:avLst/>
@@ -1679,318 +1884,113 @@
           <a:lstStyle>
             <a:lvl1pPr marL="0" indent="0" algn="ctr">
               <a:lnSpc>
-                <a:spcPts val="2350"/>
+                <a:spcPts val="1762"/>
+              </a:lnSpc>
+              <a:spcBef>
+                <a:spcPts val="0"/>
+              </a:spcBef>
+              <a:buNone/>
+              <a:defRPr sz="1350" b="0">
+                <a:solidFill>
+                  <a:srgbClr val="182232"/>
+                </a:solidFill>
+                <a:latin typeface="Space Grotesk"/>
+                <a:ea typeface="Space Grotesk"/>
+                <a:cs typeface="Space Grotesk"/>
+              </a:defRPr>
+            </a:lvl1pPr>
+          </a:lstStyle>
+          <a:p>
+            <a:r>
+              <a:rPr lang="en-US"/>
+              <a:t>03</a:t>
+            </a:r>
+          </a:p>
+        </p:txBody>
+      </p:sp>
+      <p:sp>
+        <p:nvSpPr>
+          <p:cNvPr id="126" name="Column 3 title"/>
+          <p:cNvSpPr>
+            <a:spLocks noGrp="1"/>
+          </p:cNvSpPr>
+          <p:nvPr>
+            <p:ph type="body" idx="5"/>
+          </p:nvPr>
+        </p:nvSpPr>
+        <p:spPr>
+          <a:xfrm>
+            <a:off x="6286500" y="1924050"/>
+            <a:ext cx="2057400" cy="571500"/>
+          </a:xfrm>
+          <a:prstGeom prst="rect">
+            <a:avLst/>
+          </a:prstGeom>
+        </p:spPr>
+        <p:txBody>
+          <a:bodyPr wrap="square" lIns="0" tIns="0" rIns="0" bIns="0" anchor="t">
+            <a:noAutofit/>
+          </a:bodyPr>
+          <a:lstStyle>
+            <a:lvl1pPr marL="0" indent="0" algn="l">
+              <a:lnSpc>
+                <a:spcPts val="2325"/>
+              </a:lnSpc>
+              <a:spcBef>
+                <a:spcPts val="0"/>
+              </a:spcBef>
+              <a:buNone/>
+              <a:defRPr sz="1800" b="1">
+                <a:solidFill>
+                  <a:srgbClr val="182232"/>
+                </a:solidFill>
+                <a:latin typeface="Space Grotesk"/>
+                <a:ea typeface="Space Grotesk"/>
+                <a:cs typeface="Space Grotesk"/>
+              </a:defRPr>
+            </a:lvl1pPr>
+          </a:lstStyle>
+          <a:p>
+            <a:r>
+              <a:rPr lang="en-US"/>
+              <a:t>Column title</a:t>
+            </a:r>
+          </a:p>
+        </p:txBody>
+      </p:sp>
+      <p:sp>
+        <p:nvSpPr>
+          <p:cNvPr id="127" name="Column 3 text"/>
+          <p:cNvSpPr>
+            <a:spLocks noGrp="1"/>
+          </p:cNvSpPr>
+          <p:nvPr>
+            <p:ph type="body" idx="6"/>
+          </p:nvPr>
+        </p:nvSpPr>
+        <p:spPr>
+          <a:xfrm>
+            <a:off x="6286500" y="2590800"/>
+            <a:ext cx="2057400" cy="952500"/>
+          </a:xfrm>
+          <a:prstGeom prst="rect">
+            <a:avLst/>
+          </a:prstGeom>
+        </p:spPr>
+        <p:txBody>
+          <a:bodyPr wrap="square" lIns="0" tIns="0" rIns="0" bIns="0" anchor="t">
+            <a:noAutofit/>
+          </a:bodyPr>
+          <a:lstStyle>
+            <a:lvl1pPr marL="0" indent="0" algn="l">
+              <a:lnSpc>
+                <a:spcPts val="2325"/>
               </a:lnSpc>
               <a:spcBef>
                 <a:spcPts val="0"/>
               </a:spcBef>
               <a:buNone/>
               <a:defRPr sz="1800" b="0">
-                <a:solidFill>
-                  <a:srgbClr val="182232"/>
-                </a:solidFill>
-                <a:latin typeface="Space Grotesk"/>
-                <a:ea typeface="Space Grotesk"/>
-                <a:cs typeface="Space Grotesk"/>
-              </a:defRPr>
-            </a:lvl1pPr>
-          </a:lstStyle>
-          <a:p>
-            <a:r>
-              <a:rPr lang="en-US"/>
-              <a:t>02</a:t>
-            </a:r>
-          </a:p>
-        </p:txBody>
-      </p:sp>
-      <p:sp>
-        <p:nvSpPr>
-          <p:cNvPr id="121" name="Column 2 title"/>
-          <p:cNvSpPr>
-            <a:spLocks noGrp="1"/>
-          </p:cNvSpPr>
-          <p:nvPr>
-            <p:ph type="body" idx="3"/>
-          </p:nvPr>
-        </p:nvSpPr>
-        <p:spPr>
-          <a:xfrm>
-            <a:off x="4724400" y="2565400"/>
-            <a:ext cx="2743200" cy="762000"/>
-          </a:xfrm>
-          <a:prstGeom prst="rect">
-            <a:avLst/>
-          </a:prstGeom>
-        </p:spPr>
-        <p:txBody>
-          <a:bodyPr wrap="square" lIns="0" tIns="0" rIns="0" bIns="0" anchor="t">
-            <a:noAutofit/>
-          </a:bodyPr>
-          <a:lstStyle>
-            <a:lvl1pPr marL="0" indent="0" algn="l">
-              <a:lnSpc>
-                <a:spcPts val="3100"/>
-              </a:lnSpc>
-              <a:spcBef>
-                <a:spcPts val="0"/>
-              </a:spcBef>
-              <a:buNone/>
-              <a:defRPr sz="2400" b="1">
-                <a:solidFill>
-                  <a:srgbClr val="182232"/>
-                </a:solidFill>
-                <a:latin typeface="Space Grotesk"/>
-                <a:ea typeface="Space Grotesk"/>
-                <a:cs typeface="Space Grotesk"/>
-              </a:defRPr>
-            </a:lvl1pPr>
-          </a:lstStyle>
-          <a:p>
-            <a:r>
-              <a:rPr lang="en-US"/>
-              <a:t>Column title</a:t>
-            </a:r>
-          </a:p>
-        </p:txBody>
-      </p:sp>
-      <p:sp>
-        <p:nvSpPr>
-          <p:cNvPr id="122" name="Column 2 text"/>
-          <p:cNvSpPr>
-            <a:spLocks noGrp="1"/>
-          </p:cNvSpPr>
-          <p:nvPr>
-            <p:ph type="body" idx="4"/>
-          </p:nvPr>
-        </p:nvSpPr>
-        <p:spPr>
-          <a:xfrm>
-            <a:off x="4724400" y="3454400"/>
-            <a:ext cx="2743200" cy="1270000"/>
-          </a:xfrm>
-          <a:prstGeom prst="rect">
-            <a:avLst/>
-          </a:prstGeom>
-        </p:spPr>
-        <p:txBody>
-          <a:bodyPr wrap="square" lIns="0" tIns="0" rIns="0" bIns="0" anchor="t">
-            <a:noAutofit/>
-          </a:bodyPr>
-          <a:lstStyle>
-            <a:lvl1pPr marL="0" indent="0" algn="l">
-              <a:lnSpc>
-                <a:spcPts val="3100"/>
-              </a:lnSpc>
-              <a:spcBef>
-                <a:spcPts val="0"/>
-              </a:spcBef>
-              <a:buNone/>
-              <a:defRPr sz="2400" b="0">
-                <a:solidFill>
-                  <a:srgbClr val="182232"/>
-                </a:solidFill>
-                <a:latin typeface="Space Grotesk"/>
-                <a:ea typeface="Space Grotesk"/>
-                <a:cs typeface="Space Grotesk"/>
-              </a:defRPr>
-            </a:lvl1pPr>
-          </a:lstStyle>
-          <a:p>
-            <a:r>
-              <a:rPr lang="en-US"/>
-              <a:t>One or two short lines</a:t>
-            </a:r>
-          </a:p>
-        </p:txBody>
-      </p:sp>
-      <p:sp>
-        <p:nvSpPr>
-          <p:cNvPr id="123" name="Card 3"/>
-          <p:cNvSpPr/>
-          <p:nvPr/>
-        </p:nvSpPr>
-        <p:spPr>
-          <a:xfrm>
-            <a:off x="8077200" y="1651000"/>
-            <a:ext cx="3352800" cy="3302000"/>
-          </a:xfrm>
-          <a:prstGeom prst="roundRect">
-            <a:avLst>
-              <a:gd name="adj" fmla="val 3077"/>
-            </a:avLst>
-          </a:prstGeom>
-          <a:solidFill>
-            <a:srgbClr val="F4F4F4"/>
-          </a:solidFill>
-          <a:ln>
-            <a:noFill/>
-          </a:ln>
-        </p:spPr>
-        <p:txBody>
-          <a:bodyPr/>
-          <a:lstStyle/>
-          <a:p/>
-        </p:txBody>
-      </p:sp>
-      <p:sp>
-        <p:nvSpPr>
-          <p:cNvPr id="124" name="Pill 3"/>
-          <p:cNvSpPr/>
-          <p:nvPr/>
-        </p:nvSpPr>
-        <p:spPr>
-          <a:xfrm>
-            <a:off x="8382000" y="1955800"/>
-            <a:ext cx="609600" cy="406400"/>
-          </a:xfrm>
-          <a:prstGeom prst="roundRect">
-            <a:avLst>
-              <a:gd name="adj" fmla="val 25000"/>
-            </a:avLst>
-          </a:prstGeom>
-          <a:solidFill>
-            <a:srgbClr val="B5DC3A"/>
-          </a:solidFill>
-          <a:ln>
-            <a:noFill/>
-          </a:ln>
-        </p:spPr>
-        <p:txBody>
-          <a:bodyPr/>
-          <a:lstStyle/>
-          <a:p/>
-        </p:txBody>
-      </p:sp>
-      <p:sp>
-        <p:nvSpPr>
-          <p:cNvPr id="125" name="Pill number 3"/>
-          <p:cNvSpPr txBox="1"/>
-          <p:nvPr/>
-        </p:nvSpPr>
-        <p:spPr>
-          <a:xfrm>
-            <a:off x="8382000" y="2044700"/>
-            <a:ext cx="609600" cy="254000"/>
-          </a:xfrm>
-          <a:prstGeom prst="rect">
-            <a:avLst/>
-          </a:prstGeom>
-          <a:noFill/>
-        </p:spPr>
-        <p:txBody>
-          <a:bodyPr wrap="square" lIns="0" tIns="0" rIns="0" bIns="0" anchor="t">
-            <a:noAutofit/>
-          </a:bodyPr>
-          <a:lstStyle>
-            <a:lvl1pPr marL="0" indent="0" algn="ctr">
-              <a:lnSpc>
-                <a:spcPts val="2350"/>
-              </a:lnSpc>
-              <a:spcBef>
-                <a:spcPts val="0"/>
-              </a:spcBef>
-              <a:buNone/>
-              <a:defRPr sz="1800" b="0">
-                <a:solidFill>
-                  <a:srgbClr val="182232"/>
-                </a:solidFill>
-                <a:latin typeface="Space Grotesk"/>
-                <a:ea typeface="Space Grotesk"/>
-                <a:cs typeface="Space Grotesk"/>
-              </a:defRPr>
-            </a:lvl1pPr>
-          </a:lstStyle>
-          <a:p>
-            <a:r>
-              <a:rPr lang="en-US"/>
-              <a:t>03</a:t>
-            </a:r>
-          </a:p>
-        </p:txBody>
-      </p:sp>
-      <p:sp>
-        <p:nvSpPr>
-          <p:cNvPr id="126" name="Column 3 title"/>
-          <p:cNvSpPr>
-            <a:spLocks noGrp="1"/>
-          </p:cNvSpPr>
-          <p:nvPr>
-            <p:ph type="body" idx="5"/>
-          </p:nvPr>
-        </p:nvSpPr>
-        <p:spPr>
-          <a:xfrm>
-            <a:off x="8382000" y="2565400"/>
-            <a:ext cx="2743200" cy="762000"/>
-          </a:xfrm>
-          <a:prstGeom prst="rect">
-            <a:avLst/>
-          </a:prstGeom>
-        </p:spPr>
-        <p:txBody>
-          <a:bodyPr wrap="square" lIns="0" tIns="0" rIns="0" bIns="0" anchor="t">
-            <a:noAutofit/>
-          </a:bodyPr>
-          <a:lstStyle>
-            <a:lvl1pPr marL="0" indent="0" algn="l">
-              <a:lnSpc>
-                <a:spcPts val="3100"/>
-              </a:lnSpc>
-              <a:spcBef>
-                <a:spcPts val="0"/>
-              </a:spcBef>
-              <a:buNone/>
-              <a:defRPr sz="2400" b="1">
-                <a:solidFill>
-                  <a:srgbClr val="182232"/>
-                </a:solidFill>
-                <a:latin typeface="Space Grotesk"/>
-                <a:ea typeface="Space Grotesk"/>
-                <a:cs typeface="Space Grotesk"/>
-              </a:defRPr>
-            </a:lvl1pPr>
-          </a:lstStyle>
-          <a:p>
-            <a:r>
-              <a:rPr lang="en-US"/>
-              <a:t>Column title</a:t>
-            </a:r>
-          </a:p>
-        </p:txBody>
-      </p:sp>
-      <p:sp>
-        <p:nvSpPr>
-          <p:cNvPr id="127" name="Column 3 text"/>
-          <p:cNvSpPr>
-            <a:spLocks noGrp="1"/>
-          </p:cNvSpPr>
-          <p:nvPr>
-            <p:ph type="body" idx="6"/>
-          </p:nvPr>
-        </p:nvSpPr>
-        <p:spPr>
-          <a:xfrm>
-            <a:off x="8382000" y="3454400"/>
-            <a:ext cx="2743200" cy="1270000"/>
-          </a:xfrm>
-          <a:prstGeom prst="rect">
-            <a:avLst/>
-          </a:prstGeom>
-        </p:spPr>
-        <p:txBody>
-          <a:bodyPr wrap="square" lIns="0" tIns="0" rIns="0" bIns="0" anchor="t">
-            <a:noAutofit/>
-          </a:bodyPr>
-          <a:lstStyle>
-            <a:lvl1pPr marL="0" indent="0" algn="l">
-              <a:lnSpc>
-                <a:spcPts val="3100"/>
-              </a:lnSpc>
-              <a:spcBef>
-                <a:spcPts val="0"/>
-              </a:spcBef>
-              <a:buNone/>
-              <a:defRPr sz="2400" b="0">
                 <a:solidFill>
                   <a:srgbClr val="182232"/>
                 </a:solidFill>
@@ -2062,8 +2062,8 @@
         </p:nvSpPr>
         <p:spPr>
           <a:xfrm>
-            <a:off x="762000" y="2489200"/>
-            <a:ext cx="6350000" cy="298450"/>
+            <a:off x="571500" y="1866900"/>
+            <a:ext cx="4762500" cy="223838"/>
           </a:xfrm>
           <a:prstGeom prst="rect">
             <a:avLst/>
@@ -2076,13 +2076,13 @@
           <a:lstStyle>
             <a:lvl1pPr marL="0" indent="0" algn="l">
               <a:lnSpc>
-                <a:spcPts val="2350"/>
+                <a:spcPts val="1762"/>
               </a:lnSpc>
               <a:spcBef>
                 <a:spcPts val="0"/>
               </a:spcBef>
               <a:buNone/>
-              <a:defRPr sz="1800" b="0">
+              <a:defRPr sz="1350" b="0">
                 <a:solidFill>
                   <a:srgbClr val="182232"/>
                 </a:solidFill>
@@ -2112,8 +2112,8 @@
         </p:nvSpPr>
         <p:spPr>
           <a:xfrm>
-            <a:off x="762000" y="2895600"/>
-            <a:ext cx="6350000" cy="2413000"/>
+            <a:off x="571500" y="2171700"/>
+            <a:ext cx="4762500" cy="1809750"/>
           </a:xfrm>
           <a:prstGeom prst="rect">
             <a:avLst/>
@@ -2126,19 +2126,19 @@
           <a:lstStyle>
             <a:lvl1pPr marL="0" indent="0" algn="l">
               <a:lnSpc>
-                <a:spcPts val="6300"/>
+                <a:spcPts val="4725"/>
               </a:lnSpc>
               <a:spcBef>
                 <a:spcPts val="0"/>
               </a:spcBef>
               <a:buNone/>
-              <a:defRPr sz="6000" b="0">
+              <a:defRPr sz="4500" b="1">
                 <a:solidFill>
                   <a:srgbClr val="182232"/>
                 </a:solidFill>
-                <a:latin typeface="PP Neue Machina Inktrap Smbold"/>
-                <a:ea typeface="PP Neue Machina Inktrap Smbold"/>
-                <a:cs typeface="PP Neue Machina Inktrap Smbold"/>
+                <a:latin typeface="Space Grotesk"/>
+                <a:ea typeface="Space Grotesk"/>
+                <a:cs typeface="Space Grotesk"/>
               </a:defRPr>
             </a:lvl1pPr>
           </a:lstStyle>
@@ -2204,8 +2204,8 @@
         </p:nvSpPr>
         <p:spPr>
           <a:xfrm>
-            <a:off x="762000" y="609600"/>
-            <a:ext cx="10668000" cy="609600"/>
+            <a:off x="571500" y="457200"/>
+            <a:ext cx="8001000" cy="457200"/>
           </a:xfrm>
           <a:prstGeom prst="rect">
             <a:avLst/>
@@ -2218,19 +2218,19 @@
           <a:lstStyle>
             <a:lvl1pPr marL="0" indent="0" algn="l">
               <a:lnSpc>
-                <a:spcPts val="4400"/>
+                <a:spcPts val="3300"/>
               </a:lnSpc>
               <a:spcBef>
                 <a:spcPts val="0"/>
               </a:spcBef>
               <a:buNone/>
-              <a:defRPr sz="4000" b="0">
+              <a:defRPr sz="3000" b="1">
                 <a:solidFill>
                   <a:srgbClr val="FFFCFC"/>
                 </a:solidFill>
-                <a:latin typeface="PP Neue Machina Inktrap Smbold"/>
-                <a:ea typeface="PP Neue Machina Inktrap Smbold"/>
-                <a:cs typeface="PP Neue Machina Inktrap Smbold"/>
+                <a:latin typeface="Space Grotesk"/>
+                <a:ea typeface="Space Grotesk"/>
+                <a:cs typeface="Space Grotesk"/>
               </a:defRPr>
             </a:lvl1pPr>
           </a:lstStyle>
@@ -2254,8 +2254,8 @@
         </p:nvSpPr>
         <p:spPr>
           <a:xfrm>
-            <a:off x="762000" y="1625600"/>
-            <a:ext cx="10668000" cy="298450"/>
+            <a:off x="571500" y="1219200"/>
+            <a:ext cx="8001000" cy="223838"/>
           </a:xfrm>
           <a:prstGeom prst="rect">
             <a:avLst/>
@@ -2268,13 +2268,13 @@
           <a:lstStyle>
             <a:lvl1pPr marL="0" indent="0" algn="l">
               <a:lnSpc>
-                <a:spcPts val="2350"/>
+                <a:spcPts val="1762"/>
               </a:lnSpc>
               <a:spcBef>
                 <a:spcPts val="0"/>
               </a:spcBef>
               <a:buNone/>
-              <a:defRPr sz="1800" b="0">
+              <a:defRPr sz="1350" b="0">
                 <a:solidFill>
                   <a:srgbClr val="9FA9FF"/>
                 </a:solidFill>
@@ -2304,8 +2304,8 @@
         </p:nvSpPr>
         <p:spPr>
           <a:xfrm>
-            <a:off x="762000" y="2032000"/>
-            <a:ext cx="10668000" cy="4064000"/>
+            <a:off x="571500" y="1524000"/>
+            <a:ext cx="8001000" cy="3048000"/>
           </a:xfrm>
           <a:prstGeom prst="rect">
             <a:avLst/>
@@ -2318,13 +2318,13 @@
           <a:lstStyle>
             <a:lvl1pPr marL="0" indent="0" algn="l">
               <a:lnSpc>
-                <a:spcPts val="3200"/>
+                <a:spcPts val="2400"/>
               </a:lnSpc>
               <a:spcBef>
                 <a:spcPts val="0"/>
               </a:spcBef>
               <a:buNone/>
-              <a:defRPr sz="2200" b="0">
+              <a:defRPr sz="1650" b="0">
                 <a:solidFill>
                   <a:srgbClr val="FFFCFC"/>
                 </a:solidFill>
@@ -2396,8 +2396,8 @@
         </p:nvSpPr>
         <p:spPr>
           <a:xfrm>
-            <a:off x="762000" y="1524000"/>
-            <a:ext cx="9906000" cy="2095500"/>
+            <a:off x="571500" y="1143000"/>
+            <a:ext cx="7429500" cy="1571625"/>
           </a:xfrm>
           <a:prstGeom prst="rect">
             <a:avLst/>
@@ -2410,19 +2410,19 @@
           <a:lstStyle>
             <a:lvl1pPr marL="0" indent="0" algn="l">
               <a:lnSpc>
-                <a:spcPts val="4600"/>
+                <a:spcPts val="3450"/>
               </a:lnSpc>
               <a:spcBef>
                 <a:spcPts val="0"/>
               </a:spcBef>
               <a:buNone/>
-              <a:defRPr sz="4000" b="0">
+              <a:defRPr sz="3000" b="1">
                 <a:solidFill>
                   <a:srgbClr val="182232"/>
                 </a:solidFill>
-                <a:latin typeface="PP Neue Machina Inktrap Smbold"/>
-                <a:ea typeface="PP Neue Machina Inktrap Smbold"/>
-                <a:cs typeface="PP Neue Machina Inktrap Smbold"/>
+                <a:latin typeface="Space Grotesk"/>
+                <a:ea typeface="Space Grotesk"/>
+                <a:cs typeface="Space Grotesk"/>
               </a:defRPr>
             </a:lvl1pPr>
           </a:lstStyle>
@@ -2442,8 +2442,8 @@
         </p:nvSpPr>
         <p:spPr>
           <a:xfrm>
-            <a:off x="762000" y="3810000"/>
-            <a:ext cx="381000" cy="38100"/>
+            <a:off x="571500" y="2857500"/>
+            <a:ext cx="285750" cy="28575"/>
           </a:xfrm>
           <a:prstGeom prst="rect">
             <a:avLst/>
@@ -2473,8 +2473,8 @@
         </p:nvSpPr>
         <p:spPr>
           <a:xfrm>
-            <a:off x="762000" y="4064000"/>
-            <a:ext cx="7620000" cy="393700"/>
+            <a:off x="571500" y="3048000"/>
+            <a:ext cx="5715000" cy="295275"/>
           </a:xfrm>
           <a:prstGeom prst="rect">
             <a:avLst/>
@@ -2487,13 +2487,13 @@
           <a:lstStyle>
             <a:lvl1pPr marL="0" indent="0" algn="l">
               <a:lnSpc>
-                <a:spcPts val="3100"/>
+                <a:spcPts val="2325"/>
               </a:lnSpc>
               <a:spcBef>
                 <a:spcPts val="0"/>
               </a:spcBef>
               <a:buNone/>
-              <a:defRPr sz="2400" b="1">
+              <a:defRPr sz="1800" b="1">
                 <a:solidFill>
                   <a:srgbClr val="182232"/>
                 </a:solidFill>
@@ -2523,8 +2523,8 @@
         </p:nvSpPr>
         <p:spPr>
           <a:xfrm>
-            <a:off x="762000" y="4470400"/>
-            <a:ext cx="7620000" cy="298450"/>
+            <a:off x="571500" y="3352800"/>
+            <a:ext cx="5715000" cy="223838"/>
           </a:xfrm>
           <a:prstGeom prst="rect">
             <a:avLst/>
@@ -2537,13 +2537,13 @@
           <a:lstStyle>
             <a:lvl1pPr marL="0" indent="0" algn="l">
               <a:lnSpc>
-                <a:spcPts val="2350"/>
+                <a:spcPts val="1762"/>
               </a:lnSpc>
               <a:spcBef>
                 <a:spcPts val="0"/>
               </a:spcBef>
               <a:buNone/>
-              <a:defRPr sz="1800" b="0">
+              <a:defRPr sz="1350" b="0">
                 <a:solidFill>
                   <a:srgbClr val="182232"/>
                 </a:solidFill>
@@ -2615,8 +2615,8 @@
         </p:nvSpPr>
         <p:spPr>
           <a:xfrm>
-            <a:off x="762000" y="609600"/>
-            <a:ext cx="10668000" cy="609600"/>
+            <a:off x="571500" y="457200"/>
+            <a:ext cx="8001000" cy="457200"/>
           </a:xfrm>
           <a:prstGeom prst="rect">
             <a:avLst/>
@@ -2629,19 +2629,19 @@
           <a:lstStyle>
             <a:lvl1pPr marL="0" indent="0" algn="l">
               <a:lnSpc>
-                <a:spcPts val="4400"/>
+                <a:spcPts val="3300"/>
               </a:lnSpc>
               <a:spcBef>
                 <a:spcPts val="0"/>
               </a:spcBef>
               <a:buNone/>
-              <a:defRPr sz="4000" b="0">
+              <a:defRPr sz="3000" b="1">
                 <a:solidFill>
                   <a:srgbClr val="182232"/>
                 </a:solidFill>
-                <a:latin typeface="PP Neue Machina Inktrap Smbold"/>
-                <a:ea typeface="PP Neue Machina Inktrap Smbold"/>
-                <a:cs typeface="PP Neue Machina Inktrap Smbold"/>
+                <a:latin typeface="Space Grotesk"/>
+                <a:ea typeface="Space Grotesk"/>
+                <a:cs typeface="Space Grotesk"/>
               </a:defRPr>
             </a:lvl1pPr>
           </a:lstStyle>
@@ -3278,8 +3278,8 @@
         </p:nvSpPr>
         <p:spPr>
           <a:xfrm>
-            <a:off x="736600" y="3702050"/>
-            <a:ext cx="2260600" cy="400050"/>
+            <a:off x="552450" y="2776538"/>
+            <a:ext cx="1695450" cy="300038"/>
           </a:xfrm>
           <a:prstGeom prst="roundRect">
             <a:avLst>
@@ -3507,12 +3507,12 @@
         </p:nvSpPr>
         <p:spPr>
           <a:xfrm>
-            <a:off x="3117850" y="2724150"/>
-            <a:ext cx="4806950" cy="768350"/>
+            <a:off x="2243138" y="1952625"/>
+            <a:ext cx="3190875" cy="747712"/>
           </a:xfrm>
           <a:prstGeom prst="roundRect">
             <a:avLst>
-              <a:gd name="adj" fmla="val 14049"/>
+              <a:gd name="adj" fmla="val 10828"/>
             </a:avLst>
           </a:prstGeom>
           <a:solidFill>
@@ -3717,8 +3717,8 @@
         </p:blipFill>
         <p:spPr>
           <a:xfrm>
-            <a:off x="2838450" y="1485900"/>
-            <a:ext cx="6515100" cy="4749800"/>
+            <a:off x="2128838" y="1114425"/>
+            <a:ext cx="4886325" cy="3562350"/>
           </a:xfrm>
           <a:prstGeom prst="roundRect">
             <a:avLst>
@@ -4261,8 +4261,8 @@
         </p:nvSpPr>
         <p:spPr>
           <a:xfrm>
-            <a:off x="762000" y="2540000"/>
-            <a:ext cx="3302000" cy="1651000"/>
+            <a:off x="571500" y="1905000"/>
+            <a:ext cx="2476500" cy="1238250"/>
           </a:xfrm>
           <a:prstGeom prst="roundRect">
             <a:avLst>
@@ -4292,16 +4292,16 @@
           </a:fontRef>
         </p:style>
         <p:txBody>
-          <a:bodyPr rtlCol="0" anchor="ctr" lIns="254000" rIns="254000" tIns="254000" bIns="254000" wrap="square"/>
+          <a:bodyPr rtlCol="0" anchor="ctr" lIns="190500" rIns="190500" tIns="190500" bIns="190500" wrap="square"/>
           <a:lstStyle/>
           <a:p>
             <a:pPr algn="l">
               <a:lnSpc>
-                <a:spcPts val="3100"/>
+                <a:spcPts val="2325"/>
               </a:lnSpc>
             </a:pPr>
             <a:r>
-              <a:rPr sz="2400" b="1">
+              <a:rPr sz="1800" b="1">
                 <a:solidFill>
                   <a:srgbClr val="182232"/>
                 </a:solidFill>
@@ -4322,8 +4322,8 @@
         </p:nvSpPr>
         <p:spPr>
           <a:xfrm>
-            <a:off x="762000" y="4394200"/>
-            <a:ext cx="3302000" cy="635000"/>
+            <a:off x="571500" y="3295650"/>
+            <a:ext cx="2476500" cy="476250"/>
           </a:xfrm>
           <a:prstGeom prst="rect">
             <a:avLst/>
@@ -4338,11 +4338,11 @@
           <a:p>
             <a:pPr>
               <a:lnSpc>
-                <a:spcPts val="2350"/>
+                <a:spcPts val="1762"/>
               </a:lnSpc>
             </a:pPr>
             <a:r>
-              <a:rPr sz="1800" b="0">
+              <a:rPr sz="1350" b="0">
                 <a:solidFill>
                   <a:srgbClr val="182232"/>
                 </a:solidFill>
@@ -4363,13 +4363,13 @@
         </p:nvCxnSpPr>
         <p:spPr>
           <a:xfrm>
-            <a:off x="4089400" y="3365500"/>
-            <a:ext cx="317500" cy="0"/>
+            <a:off x="3067050" y="2524125"/>
+            <a:ext cx="238125" cy="0"/>
           </a:xfrm>
           <a:prstGeom prst="line">
             <a:avLst/>
           </a:prstGeom>
-          <a:ln w="25400">
+          <a:ln w="19050">
             <a:solidFill>
               <a:srgbClr val="182232"/>
             </a:solidFill>
@@ -4399,8 +4399,8 @@
         </p:nvSpPr>
         <p:spPr>
           <a:xfrm>
-            <a:off x="4445000" y="2540000"/>
-            <a:ext cx="3302000" cy="1651000"/>
+            <a:off x="3333750" y="1905000"/>
+            <a:ext cx="2476500" cy="1238250"/>
           </a:xfrm>
           <a:prstGeom prst="roundRect">
             <a:avLst>
@@ -4430,16 +4430,16 @@
           </a:fontRef>
         </p:style>
         <p:txBody>
-          <a:bodyPr rtlCol="0" anchor="ctr" lIns="254000" rIns="254000" tIns="254000" bIns="254000" wrap="square"/>
+          <a:bodyPr rtlCol="0" anchor="ctr" lIns="190500" rIns="190500" tIns="190500" bIns="190500" wrap="square"/>
           <a:lstStyle/>
           <a:p>
             <a:pPr algn="l">
               <a:lnSpc>
-                <a:spcPts val="3100"/>
+                <a:spcPts val="2325"/>
               </a:lnSpc>
             </a:pPr>
             <a:r>
-              <a:rPr sz="2400" b="1">
+              <a:rPr sz="1800" b="1">
                 <a:solidFill>
                   <a:srgbClr val="182232"/>
                 </a:solidFill>
@@ -4460,8 +4460,8 @@
         </p:nvSpPr>
         <p:spPr>
           <a:xfrm>
-            <a:off x="4445000" y="4394200"/>
-            <a:ext cx="3302000" cy="635000"/>
+            <a:off x="3333750" y="3295650"/>
+            <a:ext cx="2476500" cy="476250"/>
           </a:xfrm>
           <a:prstGeom prst="rect">
             <a:avLst/>
@@ -4476,11 +4476,11 @@
           <a:p>
             <a:pPr>
               <a:lnSpc>
-                <a:spcPts val="2350"/>
+                <a:spcPts val="1762"/>
               </a:lnSpc>
             </a:pPr>
             <a:r>
-              <a:rPr sz="1800" b="0">
+              <a:rPr sz="1350" b="0">
                 <a:solidFill>
                   <a:srgbClr val="182232"/>
                 </a:solidFill>
@@ -4501,13 +4501,13 @@
         </p:nvCxnSpPr>
         <p:spPr>
           <a:xfrm>
-            <a:off x="7772400" y="3365500"/>
-            <a:ext cx="317500" cy="0"/>
+            <a:off x="5829300" y="2524125"/>
+            <a:ext cx="238125" cy="0"/>
           </a:xfrm>
           <a:prstGeom prst="line">
             <a:avLst/>
           </a:prstGeom>
-          <a:ln w="25400">
+          <a:ln w="19050">
             <a:solidFill>
               <a:srgbClr val="182232"/>
             </a:solidFill>
@@ -4537,8 +4537,8 @@
         </p:nvSpPr>
         <p:spPr>
           <a:xfrm>
-            <a:off x="8128000" y="2540000"/>
-            <a:ext cx="3302000" cy="1651000"/>
+            <a:off x="6096000" y="1905000"/>
+            <a:ext cx="2476500" cy="1238250"/>
           </a:xfrm>
           <a:prstGeom prst="roundRect">
             <a:avLst>
@@ -4568,16 +4568,16 @@
           </a:fontRef>
         </p:style>
         <p:txBody>
-          <a:bodyPr rtlCol="0" anchor="ctr" lIns="254000" rIns="254000" tIns="254000" bIns="254000" wrap="square"/>
+          <a:bodyPr rtlCol="0" anchor="ctr" lIns="190500" rIns="190500" tIns="190500" bIns="190500" wrap="square"/>
           <a:lstStyle/>
           <a:p>
             <a:pPr algn="l">
               <a:lnSpc>
-                <a:spcPts val="3100"/>
+                <a:spcPts val="2325"/>
               </a:lnSpc>
             </a:pPr>
             <a:r>
-              <a:rPr sz="2400" b="1">
+              <a:rPr sz="1800" b="1">
                 <a:solidFill>
                   <a:srgbClr val="182232"/>
                 </a:solidFill>
@@ -4598,8 +4598,8 @@
         </p:nvSpPr>
         <p:spPr>
           <a:xfrm>
-            <a:off x="8128000" y="4394200"/>
-            <a:ext cx="3302000" cy="635000"/>
+            <a:off x="6096000" y="3295650"/>
+            <a:ext cx="2476500" cy="476250"/>
           </a:xfrm>
           <a:prstGeom prst="rect">
             <a:avLst/>
@@ -4614,11 +4614,11 @@
           <a:p>
             <a:pPr>
               <a:lnSpc>
-                <a:spcPts val="2350"/>
+                <a:spcPts val="1762"/>
               </a:lnSpc>
             </a:pPr>
             <a:r>
-              <a:rPr sz="1800" b="0">
+              <a:rPr sz="1350" b="0">
                 <a:solidFill>
                   <a:srgbClr val="182232"/>
                 </a:solidFill>
@@ -4682,7 +4682,7 @@
     </a:clrScheme>
     <a:fontScheme name="Office">
       <a:majorFont>
-        <a:latin typeface="PP Neue Machina Inktrap Smbold"/>
+        <a:latin typeface="Space Grotesk"/>
         <a:ea typeface=""/>
         <a:cs typeface=""/>
         <a:font script="Jpan" typeface="ＭＳ Ｐゴシック"/>

</xml_diff>

<commit_message>
Content frame with castle + Devcon 8 tag, cover slides regrouped
Content slides: ground goes from paper to #EBECFE (the buidlguidl.com
page background), cards become paper, the wordmark leaves the bottom-left,
and a castle mark top-left plus a "Devcon 8" Space Mono tag top-right are
baked into content.png and content-dark.png. Headings move from y 96 to
y 120 to clear the marks; the image panel follows by 24 px.

Cover slides: the event line becomes a right-aligned Space Mono tag on the
wordmark's line. The title is bottom-anchored (grows upward, up to four
lines) with the speaker block fixed below it: name in Space Grotesk, handle
in Space Mono. Closing keeps the same pattern with the link below; Up next
puts "Up next" in the corner and the time and room in the handle slot.

Adds logos/castle-*.svg (+2x PNGs), the tag render step in logos.sh, and
updates deck.html, build_pptx.py, SKILL.md and README.md to match.

Co-Authored-By: Claude Opus 5.5 <noreply@anthropic.com>
</commit_message>
<xml_diff>
--- a/template/buidlguidl-devcon8.pptx
+++ b/template/buidlguidl-devcon8.pptx
@@ -154,13 +154,163 @@
         </p:nvSpPr>
         <p:spPr>
           <a:xfrm>
-            <a:off x="571500" y="952500"/>
-            <a:ext cx="4762500" cy="223838"/>
+            <a:off x="3429000" y="495300"/>
+            <a:ext cx="5143500" cy="223838"/>
           </a:xfrm>
           <a:prstGeom prst="rect">
             <a:avLst/>
           </a:prstGeom>
           <a:noFill/>
+        </p:spPr>
+        <p:txBody>
+          <a:bodyPr wrap="square" lIns="0" tIns="0" rIns="0" bIns="0" anchor="t">
+            <a:noAutofit/>
+          </a:bodyPr>
+          <a:lstStyle>
+            <a:lvl1pPr marL="0" indent="0" algn="r">
+              <a:lnSpc>
+                <a:spcPts val="1762"/>
+              </a:lnSpc>
+              <a:spcBef>
+                <a:spcPts val="0"/>
+              </a:spcBef>
+              <a:buNone/>
+              <a:defRPr sz="1350" b="0">
+                <a:solidFill>
+                  <a:srgbClr val="182232"/>
+                </a:solidFill>
+                <a:latin typeface="Space Mono"/>
+                <a:ea typeface="Space Mono"/>
+                <a:cs typeface="Space Mono"/>
+              </a:defRPr>
+            </a:lvl1pPr>
+          </a:lstStyle>
+          <a:p>
+            <a:r>
+              <a:rPr lang="en-US"/>
+              <a:t>Devcon 8 · Builder Enablement &amp; BuidlGuidl</a:t>
+            </a:r>
+          </a:p>
+        </p:txBody>
+      </p:sp>
+      <p:sp>
+        <p:nvSpPr>
+          <p:cNvPr id="102" name="Talk title"/>
+          <p:cNvSpPr>
+            <a:spLocks noGrp="1"/>
+          </p:cNvSpPr>
+          <p:nvPr>
+            <p:ph type="title"/>
+          </p:nvPr>
+        </p:nvSpPr>
+        <p:spPr>
+          <a:xfrm>
+            <a:off x="571500" y="895350"/>
+            <a:ext cx="4000500" cy="1924050"/>
+          </a:xfrm>
+          <a:prstGeom prst="rect">
+            <a:avLst/>
+          </a:prstGeom>
+        </p:spPr>
+        <p:txBody>
+          <a:bodyPr wrap="square" lIns="0" tIns="0" rIns="0" bIns="0" anchor="b">
+            <a:noAutofit/>
+          </a:bodyPr>
+          <a:lstStyle>
+            <a:lvl1pPr marL="0" indent="0" algn="l">
+              <a:lnSpc>
+                <a:spcPts val="3788"/>
+              </a:lnSpc>
+              <a:spcBef>
+                <a:spcPts val="0"/>
+              </a:spcBef>
+              <a:buNone/>
+              <a:defRPr sz="3600" b="1">
+                <a:solidFill>
+                  <a:srgbClr val="182232"/>
+                </a:solidFill>
+                <a:latin typeface="Space Grotesk"/>
+                <a:ea typeface="Space Grotesk"/>
+                <a:cs typeface="Space Grotesk"/>
+              </a:defRPr>
+            </a:lvl1pPr>
+          </a:lstStyle>
+          <a:p>
+            <a:r>
+              <a:rPr lang="en-US"/>
+              <a:t>Talk title</a:t>
+            </a:r>
+          </a:p>
+        </p:txBody>
+      </p:sp>
+      <p:sp>
+        <p:nvSpPr>
+          <p:cNvPr id="103" name="Speaker name"/>
+          <p:cNvSpPr>
+            <a:spLocks noGrp="1"/>
+          </p:cNvSpPr>
+          <p:nvPr>
+            <p:ph type="body" idx="1"/>
+          </p:nvPr>
+        </p:nvSpPr>
+        <p:spPr>
+          <a:xfrm>
+            <a:off x="571500" y="3086100"/>
+            <a:ext cx="4000500" cy="295275"/>
+          </a:xfrm>
+          <a:prstGeom prst="rect">
+            <a:avLst/>
+          </a:prstGeom>
+        </p:spPr>
+        <p:txBody>
+          <a:bodyPr wrap="square" lIns="0" tIns="0" rIns="0" bIns="0" anchor="t">
+            <a:noAutofit/>
+          </a:bodyPr>
+          <a:lstStyle>
+            <a:lvl1pPr marL="0" indent="0" algn="l">
+              <a:lnSpc>
+                <a:spcPts val="2325"/>
+              </a:lnSpc>
+              <a:spcBef>
+                <a:spcPts val="0"/>
+              </a:spcBef>
+              <a:buNone/>
+              <a:defRPr sz="1800" b="1">
+                <a:solidFill>
+                  <a:srgbClr val="182232"/>
+                </a:solidFill>
+                <a:latin typeface="Space Grotesk"/>
+                <a:ea typeface="Space Grotesk"/>
+                <a:cs typeface="Space Grotesk"/>
+              </a:defRPr>
+            </a:lvl1pPr>
+          </a:lstStyle>
+          <a:p>
+            <a:r>
+              <a:rPr lang="en-US"/>
+              <a:t>Speaker name</a:t>
+            </a:r>
+          </a:p>
+        </p:txBody>
+      </p:sp>
+      <p:sp>
+        <p:nvSpPr>
+          <p:cNvPr id="104" name="Handle"/>
+          <p:cNvSpPr>
+            <a:spLocks noGrp="1"/>
+          </p:cNvSpPr>
+          <p:nvPr>
+            <p:ph type="body" idx="2"/>
+          </p:nvPr>
+        </p:nvSpPr>
+        <p:spPr>
+          <a:xfrm>
+            <a:off x="571500" y="3390900"/>
+            <a:ext cx="4000500" cy="223838"/>
+          </a:xfrm>
+          <a:prstGeom prst="rect">
+            <a:avLst/>
+          </a:prstGeom>
         </p:spPr>
         <p:txBody>
           <a:bodyPr wrap="square" lIns="0" tIns="0" rIns="0" bIns="0" anchor="t">
@@ -179,166 +329,16 @@
                 <a:solidFill>
                   <a:srgbClr val="182232"/>
                 </a:solidFill>
-                <a:latin typeface="Space Grotesk"/>
-                <a:ea typeface="Space Grotesk"/>
-                <a:cs typeface="Space Grotesk"/>
+                <a:latin typeface="Space Mono"/>
+                <a:ea typeface="Space Mono"/>
+                <a:cs typeface="Space Mono"/>
               </a:defRPr>
             </a:lvl1pPr>
           </a:lstStyle>
           <a:p>
             <a:r>
               <a:rPr lang="en-US"/>
-              <a:t>Devcon 8 · Builder Enablement &amp; BuidlGuidl</a:t>
-            </a:r>
-          </a:p>
-        </p:txBody>
-      </p:sp>
-      <p:sp>
-        <p:nvSpPr>
-          <p:cNvPr id="102" name="Talk title"/>
-          <p:cNvSpPr>
-            <a:spLocks noGrp="1"/>
-          </p:cNvSpPr>
-          <p:nvPr>
-            <p:ph type="title"/>
-          </p:nvPr>
-        </p:nvSpPr>
-        <p:spPr>
-          <a:xfrm>
-            <a:off x="571500" y="1333500"/>
-            <a:ext cx="4000500" cy="1476375"/>
-          </a:xfrm>
-          <a:prstGeom prst="rect">
-            <a:avLst/>
-          </a:prstGeom>
-        </p:spPr>
-        <p:txBody>
-          <a:bodyPr wrap="square" lIns="0" tIns="0" rIns="0" bIns="0" anchor="t">
-            <a:noAutofit/>
-          </a:bodyPr>
-          <a:lstStyle>
-            <a:lvl1pPr marL="0" indent="0" algn="l">
-              <a:lnSpc>
-                <a:spcPts val="3788"/>
-              </a:lnSpc>
-              <a:spcBef>
-                <a:spcPts val="0"/>
-              </a:spcBef>
-              <a:buNone/>
-              <a:defRPr sz="3600" b="1">
-                <a:solidFill>
-                  <a:srgbClr val="182232"/>
-                </a:solidFill>
-                <a:latin typeface="Space Grotesk"/>
-                <a:ea typeface="Space Grotesk"/>
-                <a:cs typeface="Space Grotesk"/>
-              </a:defRPr>
-            </a:lvl1pPr>
-          </a:lstStyle>
-          <a:p>
-            <a:r>
-              <a:rPr lang="en-US"/>
-              <a:t>Talk title</a:t>
-            </a:r>
-          </a:p>
-        </p:txBody>
-      </p:sp>
-      <p:sp>
-        <p:nvSpPr>
-          <p:cNvPr id="103" name="Speaker name"/>
-          <p:cNvSpPr>
-            <a:spLocks noGrp="1"/>
-          </p:cNvSpPr>
-          <p:nvPr>
-            <p:ph type="body" idx="1"/>
-          </p:nvPr>
-        </p:nvSpPr>
-        <p:spPr>
-          <a:xfrm>
-            <a:off x="571500" y="2971800"/>
-            <a:ext cx="4286250" cy="295275"/>
-          </a:xfrm>
-          <a:prstGeom prst="rect">
-            <a:avLst/>
-          </a:prstGeom>
-        </p:spPr>
-        <p:txBody>
-          <a:bodyPr wrap="square" lIns="0" tIns="0" rIns="0" bIns="0" anchor="t">
-            <a:noAutofit/>
-          </a:bodyPr>
-          <a:lstStyle>
-            <a:lvl1pPr marL="0" indent="0" algn="l">
-              <a:lnSpc>
-                <a:spcPts val="2325"/>
-              </a:lnSpc>
-              <a:spcBef>
-                <a:spcPts val="0"/>
-              </a:spcBef>
-              <a:buNone/>
-              <a:defRPr sz="1800" b="1">
-                <a:solidFill>
-                  <a:srgbClr val="182232"/>
-                </a:solidFill>
-                <a:latin typeface="Space Grotesk"/>
-                <a:ea typeface="Space Grotesk"/>
-                <a:cs typeface="Space Grotesk"/>
-              </a:defRPr>
-            </a:lvl1pPr>
-          </a:lstStyle>
-          <a:p>
-            <a:r>
-              <a:rPr lang="en-US"/>
-              <a:t>Speaker name</a:t>
-            </a:r>
-          </a:p>
-        </p:txBody>
-      </p:sp>
-      <p:sp>
-        <p:nvSpPr>
-          <p:cNvPr id="104" name="Role or handle"/>
-          <p:cNvSpPr>
-            <a:spLocks noGrp="1"/>
-          </p:cNvSpPr>
-          <p:nvPr>
-            <p:ph type="body" idx="2"/>
-          </p:nvPr>
-        </p:nvSpPr>
-        <p:spPr>
-          <a:xfrm>
-            <a:off x="571500" y="3276600"/>
-            <a:ext cx="4286250" cy="223838"/>
-          </a:xfrm>
-          <a:prstGeom prst="rect">
-            <a:avLst/>
-          </a:prstGeom>
-        </p:spPr>
-        <p:txBody>
-          <a:bodyPr wrap="square" lIns="0" tIns="0" rIns="0" bIns="0" anchor="t">
-            <a:noAutofit/>
-          </a:bodyPr>
-          <a:lstStyle>
-            <a:lvl1pPr marL="0" indent="0" algn="l">
-              <a:lnSpc>
-                <a:spcPts val="1762"/>
-              </a:lnSpc>
-              <a:spcBef>
-                <a:spcPts val="0"/>
-              </a:spcBef>
-              <a:buNone/>
-              <a:defRPr sz="1350" b="0">
-                <a:solidFill>
-                  <a:srgbClr val="182232"/>
-                </a:solidFill>
-                <a:latin typeface="Space Grotesk"/>
-                <a:ea typeface="Space Grotesk"/>
-                <a:cs typeface="Space Grotesk"/>
-              </a:defRPr>
-            </a:lvl1pPr>
-          </a:lstStyle>
-          <a:p>
-            <a:r>
-              <a:rPr lang="en-US"/>
-              <a:t>Role · @handle</a:t>
+              <a:t>@handle</a:t>
             </a:r>
           </a:p>
         </p:txBody>
@@ -393,13 +393,163 @@
         </p:nvSpPr>
         <p:spPr>
           <a:xfrm>
-            <a:off x="571500" y="952500"/>
-            <a:ext cx="4762500" cy="223838"/>
+            <a:off x="3429000" y="495300"/>
+            <a:ext cx="5143500" cy="223838"/>
           </a:xfrm>
           <a:prstGeom prst="rect">
             <a:avLst/>
           </a:prstGeom>
           <a:noFill/>
+        </p:spPr>
+        <p:txBody>
+          <a:bodyPr wrap="square" lIns="0" tIns="0" rIns="0" bIns="0" anchor="t">
+            <a:noAutofit/>
+          </a:bodyPr>
+          <a:lstStyle>
+            <a:lvl1pPr marL="0" indent="0" algn="r">
+              <a:lnSpc>
+                <a:spcPts val="1762"/>
+              </a:lnSpc>
+              <a:spcBef>
+                <a:spcPts val="0"/>
+              </a:spcBef>
+              <a:buNone/>
+              <a:defRPr sz="1350" b="0">
+                <a:solidFill>
+                  <a:srgbClr val="182232"/>
+                </a:solidFill>
+                <a:latin typeface="Space Mono"/>
+                <a:ea typeface="Space Mono"/>
+                <a:cs typeface="Space Mono"/>
+              </a:defRPr>
+            </a:lvl1pPr>
+          </a:lstStyle>
+          <a:p>
+            <a:r>
+              <a:rPr lang="en-US"/>
+              <a:t>Devcon 8 · Builder Enablement &amp; BuidlGuidl</a:t>
+            </a:r>
+          </a:p>
+        </p:txBody>
+      </p:sp>
+      <p:sp>
+        <p:nvSpPr>
+          <p:cNvPr id="139" name="Thanks"/>
+          <p:cNvSpPr>
+            <a:spLocks noGrp="1"/>
+          </p:cNvSpPr>
+          <p:nvPr>
+            <p:ph type="title"/>
+          </p:nvPr>
+        </p:nvSpPr>
+        <p:spPr>
+          <a:xfrm>
+            <a:off x="571500" y="895350"/>
+            <a:ext cx="4000500" cy="1352550"/>
+          </a:xfrm>
+          <a:prstGeom prst="rect">
+            <a:avLst/>
+          </a:prstGeom>
+        </p:spPr>
+        <p:txBody>
+          <a:bodyPr wrap="square" lIns="0" tIns="0" rIns="0" bIns="0" anchor="b">
+            <a:noAutofit/>
+          </a:bodyPr>
+          <a:lstStyle>
+            <a:lvl1pPr marL="0" indent="0" algn="l">
+              <a:lnSpc>
+                <a:spcPts val="3788"/>
+              </a:lnSpc>
+              <a:spcBef>
+                <a:spcPts val="0"/>
+              </a:spcBef>
+              <a:buNone/>
+              <a:defRPr sz="3600" b="1">
+                <a:solidFill>
+                  <a:srgbClr val="182232"/>
+                </a:solidFill>
+                <a:latin typeface="Space Grotesk"/>
+                <a:ea typeface="Space Grotesk"/>
+                <a:cs typeface="Space Grotesk"/>
+              </a:defRPr>
+            </a:lvl1pPr>
+          </a:lstStyle>
+          <a:p>
+            <a:r>
+              <a:rPr lang="en-US"/>
+              <a:t>Thanks</a:t>
+            </a:r>
+          </a:p>
+        </p:txBody>
+      </p:sp>
+      <p:sp>
+        <p:nvSpPr>
+          <p:cNvPr id="140" name="Speaker name"/>
+          <p:cNvSpPr>
+            <a:spLocks noGrp="1"/>
+          </p:cNvSpPr>
+          <p:nvPr>
+            <p:ph type="body" idx="1"/>
+          </p:nvPr>
+        </p:nvSpPr>
+        <p:spPr>
+          <a:xfrm>
+            <a:off x="571500" y="2514600"/>
+            <a:ext cx="4000500" cy="295275"/>
+          </a:xfrm>
+          <a:prstGeom prst="rect">
+            <a:avLst/>
+          </a:prstGeom>
+        </p:spPr>
+        <p:txBody>
+          <a:bodyPr wrap="square" lIns="0" tIns="0" rIns="0" bIns="0" anchor="t">
+            <a:noAutofit/>
+          </a:bodyPr>
+          <a:lstStyle>
+            <a:lvl1pPr marL="0" indent="0" algn="l">
+              <a:lnSpc>
+                <a:spcPts val="2325"/>
+              </a:lnSpc>
+              <a:spcBef>
+                <a:spcPts val="0"/>
+              </a:spcBef>
+              <a:buNone/>
+              <a:defRPr sz="1800" b="1">
+                <a:solidFill>
+                  <a:srgbClr val="182232"/>
+                </a:solidFill>
+                <a:latin typeface="Space Grotesk"/>
+                <a:ea typeface="Space Grotesk"/>
+                <a:cs typeface="Space Grotesk"/>
+              </a:defRPr>
+            </a:lvl1pPr>
+          </a:lstStyle>
+          <a:p>
+            <a:r>
+              <a:rPr lang="en-US"/>
+              <a:t>Speaker name</a:t>
+            </a:r>
+          </a:p>
+        </p:txBody>
+      </p:sp>
+      <p:sp>
+        <p:nvSpPr>
+          <p:cNvPr id="141" name="Handles"/>
+          <p:cNvSpPr>
+            <a:spLocks noGrp="1"/>
+          </p:cNvSpPr>
+          <p:nvPr>
+            <p:ph type="body" idx="2"/>
+          </p:nvPr>
+        </p:nvSpPr>
+        <p:spPr>
+          <a:xfrm>
+            <a:off x="571500" y="2819400"/>
+            <a:ext cx="4000500" cy="223838"/>
+          </a:xfrm>
+          <a:prstGeom prst="rect">
+            <a:avLst/>
+          </a:prstGeom>
         </p:spPr>
         <p:txBody>
           <a:bodyPr wrap="square" lIns="0" tIns="0" rIns="0" bIns="0" anchor="t">
@@ -418,165 +568,15 @@
                 <a:solidFill>
                   <a:srgbClr val="182232"/>
                 </a:solidFill>
-                <a:latin typeface="Space Grotesk"/>
-                <a:ea typeface="Space Grotesk"/>
-                <a:cs typeface="Space Grotesk"/>
+                <a:latin typeface="Space Mono"/>
+                <a:ea typeface="Space Mono"/>
+                <a:cs typeface="Space Mono"/>
               </a:defRPr>
             </a:lvl1pPr>
           </a:lstStyle>
           <a:p>
             <a:r>
               <a:rPr lang="en-US"/>
-              <a:t>Devcon 8 · Builder Enablement &amp; BuidlGuidl</a:t>
-            </a:r>
-          </a:p>
-        </p:txBody>
-      </p:sp>
-      <p:sp>
-        <p:nvSpPr>
-          <p:cNvPr id="139" name="Thanks"/>
-          <p:cNvSpPr>
-            <a:spLocks noGrp="1"/>
-          </p:cNvSpPr>
-          <p:nvPr>
-            <p:ph type="title"/>
-          </p:nvPr>
-        </p:nvSpPr>
-        <p:spPr>
-          <a:xfrm>
-            <a:off x="571500" y="1333500"/>
-            <a:ext cx="4000500" cy="523875"/>
-          </a:xfrm>
-          <a:prstGeom prst="rect">
-            <a:avLst/>
-          </a:prstGeom>
-        </p:spPr>
-        <p:txBody>
-          <a:bodyPr wrap="square" lIns="0" tIns="0" rIns="0" bIns="0" anchor="t">
-            <a:noAutofit/>
-          </a:bodyPr>
-          <a:lstStyle>
-            <a:lvl1pPr marL="0" indent="0" algn="l">
-              <a:lnSpc>
-                <a:spcPts val="3788"/>
-              </a:lnSpc>
-              <a:spcBef>
-                <a:spcPts val="0"/>
-              </a:spcBef>
-              <a:buNone/>
-              <a:defRPr sz="3600" b="1">
-                <a:solidFill>
-                  <a:srgbClr val="182232"/>
-                </a:solidFill>
-                <a:latin typeface="Space Grotesk"/>
-                <a:ea typeface="Space Grotesk"/>
-                <a:cs typeface="Space Grotesk"/>
-              </a:defRPr>
-            </a:lvl1pPr>
-          </a:lstStyle>
-          <a:p>
-            <a:r>
-              <a:rPr lang="en-US"/>
-              <a:t>Thanks</a:t>
-            </a:r>
-          </a:p>
-        </p:txBody>
-      </p:sp>
-      <p:sp>
-        <p:nvSpPr>
-          <p:cNvPr id="140" name="Speaker name"/>
-          <p:cNvSpPr>
-            <a:spLocks noGrp="1"/>
-          </p:cNvSpPr>
-          <p:nvPr>
-            <p:ph type="body" idx="1"/>
-          </p:nvPr>
-        </p:nvSpPr>
-        <p:spPr>
-          <a:xfrm>
-            <a:off x="571500" y="2095500"/>
-            <a:ext cx="4191000" cy="295275"/>
-          </a:xfrm>
-          <a:prstGeom prst="rect">
-            <a:avLst/>
-          </a:prstGeom>
-        </p:spPr>
-        <p:txBody>
-          <a:bodyPr wrap="square" lIns="0" tIns="0" rIns="0" bIns="0" anchor="t">
-            <a:noAutofit/>
-          </a:bodyPr>
-          <a:lstStyle>
-            <a:lvl1pPr marL="0" indent="0" algn="l">
-              <a:lnSpc>
-                <a:spcPts val="2325"/>
-              </a:lnSpc>
-              <a:spcBef>
-                <a:spcPts val="0"/>
-              </a:spcBef>
-              <a:buNone/>
-              <a:defRPr sz="1800" b="1">
-                <a:solidFill>
-                  <a:srgbClr val="182232"/>
-                </a:solidFill>
-                <a:latin typeface="Space Grotesk"/>
-                <a:ea typeface="Space Grotesk"/>
-                <a:cs typeface="Space Grotesk"/>
-              </a:defRPr>
-            </a:lvl1pPr>
-          </a:lstStyle>
-          <a:p>
-            <a:r>
-              <a:rPr lang="en-US"/>
-              <a:t>Speaker name</a:t>
-            </a:r>
-          </a:p>
-        </p:txBody>
-      </p:sp>
-      <p:sp>
-        <p:nvSpPr>
-          <p:cNvPr id="141" name="Handles"/>
-          <p:cNvSpPr>
-            <a:spLocks noGrp="1"/>
-          </p:cNvSpPr>
-          <p:nvPr>
-            <p:ph type="body" idx="2"/>
-          </p:nvPr>
-        </p:nvSpPr>
-        <p:spPr>
-          <a:xfrm>
-            <a:off x="571500" y="2400300"/>
-            <a:ext cx="4191000" cy="295275"/>
-          </a:xfrm>
-          <a:prstGeom prst="rect">
-            <a:avLst/>
-          </a:prstGeom>
-        </p:spPr>
-        <p:txBody>
-          <a:bodyPr wrap="square" lIns="0" tIns="0" rIns="0" bIns="0" anchor="t">
-            <a:noAutofit/>
-          </a:bodyPr>
-          <a:lstStyle>
-            <a:lvl1pPr marL="0" indent="0" algn="l">
-              <a:lnSpc>
-                <a:spcPts val="2325"/>
-              </a:lnSpc>
-              <a:spcBef>
-                <a:spcPts val="0"/>
-              </a:spcBef>
-              <a:buNone/>
-              <a:defRPr sz="1800" b="0">
-                <a:solidFill>
-                  <a:srgbClr val="182232"/>
-                </a:solidFill>
-                <a:latin typeface="Space Grotesk"/>
-                <a:ea typeface="Space Grotesk"/>
-                <a:cs typeface="Space Grotesk"/>
-              </a:defRPr>
-            </a:lvl1pPr>
-          </a:lstStyle>
-          <a:p>
-            <a:r>
-              <a:rPr lang="en-US"/>
               <a:t>@handle on X and GitHub</a:t>
             </a:r>
           </a:p>
@@ -594,8 +594,8 @@
         </p:nvSpPr>
         <p:spPr>
           <a:xfrm>
-            <a:off x="571500" y="2781300"/>
-            <a:ext cx="4191000" cy="295275"/>
+            <a:off x="571500" y="3276600"/>
+            <a:ext cx="4000500" cy="295275"/>
           </a:xfrm>
           <a:prstGeom prst="rect">
             <a:avLst/>
@@ -682,13 +682,163 @@
         </p:nvSpPr>
         <p:spPr>
           <a:xfrm>
-            <a:off x="571500" y="952500"/>
-            <a:ext cx="4762500" cy="223838"/>
+            <a:off x="3429000" y="495300"/>
+            <a:ext cx="5143500" cy="223838"/>
           </a:xfrm>
           <a:prstGeom prst="rect">
             <a:avLst/>
           </a:prstGeom>
           <a:noFill/>
+        </p:spPr>
+        <p:txBody>
+          <a:bodyPr wrap="square" lIns="0" tIns="0" rIns="0" bIns="0" anchor="t">
+            <a:noAutofit/>
+          </a:bodyPr>
+          <a:lstStyle>
+            <a:lvl1pPr marL="0" indent="0" algn="r">
+              <a:lnSpc>
+                <a:spcPts val="1762"/>
+              </a:lnSpc>
+              <a:spcBef>
+                <a:spcPts val="0"/>
+              </a:spcBef>
+              <a:buNone/>
+              <a:defRPr sz="1350" b="0">
+                <a:solidFill>
+                  <a:srgbClr val="182232"/>
+                </a:solidFill>
+                <a:latin typeface="Space Mono"/>
+                <a:ea typeface="Space Mono"/>
+                <a:cs typeface="Space Mono"/>
+              </a:defRPr>
+            </a:lvl1pPr>
+          </a:lstStyle>
+          <a:p>
+            <a:r>
+              <a:rPr lang="en-US"/>
+              <a:t>Up next</a:t>
+            </a:r>
+          </a:p>
+        </p:txBody>
+      </p:sp>
+      <p:sp>
+        <p:nvSpPr>
+          <p:cNvPr id="144" name="Talk title"/>
+          <p:cNvSpPr>
+            <a:spLocks noGrp="1"/>
+          </p:cNvSpPr>
+          <p:nvPr>
+            <p:ph type="title"/>
+          </p:nvPr>
+        </p:nvSpPr>
+        <p:spPr>
+          <a:xfrm>
+            <a:off x="571500" y="895350"/>
+            <a:ext cx="4000500" cy="1924050"/>
+          </a:xfrm>
+          <a:prstGeom prst="rect">
+            <a:avLst/>
+          </a:prstGeom>
+        </p:spPr>
+        <p:txBody>
+          <a:bodyPr wrap="square" lIns="0" tIns="0" rIns="0" bIns="0" anchor="b">
+            <a:noAutofit/>
+          </a:bodyPr>
+          <a:lstStyle>
+            <a:lvl1pPr marL="0" indent="0" algn="l">
+              <a:lnSpc>
+                <a:spcPts val="3788"/>
+              </a:lnSpc>
+              <a:spcBef>
+                <a:spcPts val="0"/>
+              </a:spcBef>
+              <a:buNone/>
+              <a:defRPr sz="3600" b="1">
+                <a:solidFill>
+                  <a:srgbClr val="182232"/>
+                </a:solidFill>
+                <a:latin typeface="Space Grotesk"/>
+                <a:ea typeface="Space Grotesk"/>
+                <a:cs typeface="Space Grotesk"/>
+              </a:defRPr>
+            </a:lvl1pPr>
+          </a:lstStyle>
+          <a:p>
+            <a:r>
+              <a:rPr lang="en-US"/>
+              <a:t>Talk title</a:t>
+            </a:r>
+          </a:p>
+        </p:txBody>
+      </p:sp>
+      <p:sp>
+        <p:nvSpPr>
+          <p:cNvPr id="145" name="Speaker"/>
+          <p:cNvSpPr>
+            <a:spLocks noGrp="1"/>
+          </p:cNvSpPr>
+          <p:nvPr>
+            <p:ph type="body" idx="1"/>
+          </p:nvPr>
+        </p:nvSpPr>
+        <p:spPr>
+          <a:xfrm>
+            <a:off x="571500" y="3086100"/>
+            <a:ext cx="4000500" cy="295275"/>
+          </a:xfrm>
+          <a:prstGeom prst="rect">
+            <a:avLst/>
+          </a:prstGeom>
+        </p:spPr>
+        <p:txBody>
+          <a:bodyPr wrap="square" lIns="0" tIns="0" rIns="0" bIns="0" anchor="t">
+            <a:noAutofit/>
+          </a:bodyPr>
+          <a:lstStyle>
+            <a:lvl1pPr marL="0" indent="0" algn="l">
+              <a:lnSpc>
+                <a:spcPts val="2325"/>
+              </a:lnSpc>
+              <a:spcBef>
+                <a:spcPts val="0"/>
+              </a:spcBef>
+              <a:buNone/>
+              <a:defRPr sz="1800" b="1">
+                <a:solidFill>
+                  <a:srgbClr val="182232"/>
+                </a:solidFill>
+                <a:latin typeface="Space Grotesk"/>
+                <a:ea typeface="Space Grotesk"/>
+                <a:cs typeface="Space Grotesk"/>
+              </a:defRPr>
+            </a:lvl1pPr>
+          </a:lstStyle>
+          <a:p>
+            <a:r>
+              <a:rPr lang="en-US"/>
+              <a:t>Speaker name</a:t>
+            </a:r>
+          </a:p>
+        </p:txBody>
+      </p:sp>
+      <p:sp>
+        <p:nvSpPr>
+          <p:cNvPr id="146" name="Time and room"/>
+          <p:cNvSpPr>
+            <a:spLocks noGrp="1"/>
+          </p:cNvSpPr>
+          <p:nvPr>
+            <p:ph type="body" idx="2"/>
+          </p:nvPr>
+        </p:nvSpPr>
+        <p:spPr>
+          <a:xfrm>
+            <a:off x="571500" y="3390900"/>
+            <a:ext cx="4000500" cy="223838"/>
+          </a:xfrm>
+          <a:prstGeom prst="rect">
+            <a:avLst/>
+          </a:prstGeom>
         </p:spPr>
         <p:txBody>
           <a:bodyPr wrap="square" lIns="0" tIns="0" rIns="0" bIns="0" anchor="t">
@@ -707,159 +857,9 @@
                 <a:solidFill>
                   <a:srgbClr val="182232"/>
                 </a:solidFill>
-                <a:latin typeface="Space Grotesk"/>
-                <a:ea typeface="Space Grotesk"/>
-                <a:cs typeface="Space Grotesk"/>
-              </a:defRPr>
-            </a:lvl1pPr>
-          </a:lstStyle>
-          <a:p>
-            <a:r>
-              <a:rPr lang="en-US"/>
-              <a:t>Up next</a:t>
-            </a:r>
-          </a:p>
-        </p:txBody>
-      </p:sp>
-      <p:sp>
-        <p:nvSpPr>
-          <p:cNvPr id="144" name="Talk title"/>
-          <p:cNvSpPr>
-            <a:spLocks noGrp="1"/>
-          </p:cNvSpPr>
-          <p:nvPr>
-            <p:ph type="title"/>
-          </p:nvPr>
-        </p:nvSpPr>
-        <p:spPr>
-          <a:xfrm>
-            <a:off x="571500" y="1333500"/>
-            <a:ext cx="4000500" cy="1476375"/>
-          </a:xfrm>
-          <a:prstGeom prst="rect">
-            <a:avLst/>
-          </a:prstGeom>
-        </p:spPr>
-        <p:txBody>
-          <a:bodyPr wrap="square" lIns="0" tIns="0" rIns="0" bIns="0" anchor="t">
-            <a:noAutofit/>
-          </a:bodyPr>
-          <a:lstStyle>
-            <a:lvl1pPr marL="0" indent="0" algn="l">
-              <a:lnSpc>
-                <a:spcPts val="3788"/>
-              </a:lnSpc>
-              <a:spcBef>
-                <a:spcPts val="0"/>
-              </a:spcBef>
-              <a:buNone/>
-              <a:defRPr sz="3600" b="1">
-                <a:solidFill>
-                  <a:srgbClr val="182232"/>
-                </a:solidFill>
-                <a:latin typeface="Space Grotesk"/>
-                <a:ea typeface="Space Grotesk"/>
-                <a:cs typeface="Space Grotesk"/>
-              </a:defRPr>
-            </a:lvl1pPr>
-          </a:lstStyle>
-          <a:p>
-            <a:r>
-              <a:rPr lang="en-US"/>
-              <a:t>Talk title</a:t>
-            </a:r>
-          </a:p>
-        </p:txBody>
-      </p:sp>
-      <p:sp>
-        <p:nvSpPr>
-          <p:cNvPr id="145" name="Speaker"/>
-          <p:cNvSpPr>
-            <a:spLocks noGrp="1"/>
-          </p:cNvSpPr>
-          <p:nvPr>
-            <p:ph type="body" idx="1"/>
-          </p:nvPr>
-        </p:nvSpPr>
-        <p:spPr>
-          <a:xfrm>
-            <a:off x="571500" y="2971800"/>
-            <a:ext cx="4286250" cy="295275"/>
-          </a:xfrm>
-          <a:prstGeom prst="rect">
-            <a:avLst/>
-          </a:prstGeom>
-        </p:spPr>
-        <p:txBody>
-          <a:bodyPr wrap="square" lIns="0" tIns="0" rIns="0" bIns="0" anchor="t">
-            <a:noAutofit/>
-          </a:bodyPr>
-          <a:lstStyle>
-            <a:lvl1pPr marL="0" indent="0" algn="l">
-              <a:lnSpc>
-                <a:spcPts val="2325"/>
-              </a:lnSpc>
-              <a:spcBef>
-                <a:spcPts val="0"/>
-              </a:spcBef>
-              <a:buNone/>
-              <a:defRPr sz="1800" b="1">
-                <a:solidFill>
-                  <a:srgbClr val="182232"/>
-                </a:solidFill>
-                <a:latin typeface="Space Grotesk"/>
-                <a:ea typeface="Space Grotesk"/>
-                <a:cs typeface="Space Grotesk"/>
-              </a:defRPr>
-            </a:lvl1pPr>
-          </a:lstStyle>
-          <a:p>
-            <a:r>
-              <a:rPr lang="en-US"/>
-              <a:t>Speaker, affiliation</a:t>
-            </a:r>
-          </a:p>
-        </p:txBody>
-      </p:sp>
-      <p:sp>
-        <p:nvSpPr>
-          <p:cNvPr id="146" name="Time and room"/>
-          <p:cNvSpPr>
-            <a:spLocks noGrp="1"/>
-          </p:cNvSpPr>
-          <p:nvPr>
-            <p:ph type="body" idx="2"/>
-          </p:nvPr>
-        </p:nvSpPr>
-        <p:spPr>
-          <a:xfrm>
-            <a:off x="571500" y="3276600"/>
-            <a:ext cx="4286250" cy="295275"/>
-          </a:xfrm>
-          <a:prstGeom prst="rect">
-            <a:avLst/>
-          </a:prstGeom>
-        </p:spPr>
-        <p:txBody>
-          <a:bodyPr wrap="square" lIns="0" tIns="0" rIns="0" bIns="0" anchor="t">
-            <a:noAutofit/>
-          </a:bodyPr>
-          <a:lstStyle>
-            <a:lvl1pPr marL="0" indent="0" algn="l">
-              <a:lnSpc>
-                <a:spcPts val="2325"/>
-              </a:lnSpc>
-              <a:spcBef>
-                <a:spcPts val="0"/>
-              </a:spcBef>
-              <a:buNone/>
-              <a:defRPr sz="1800" b="0">
-                <a:solidFill>
-                  <a:srgbClr val="182232"/>
-                </a:solidFill>
-                <a:latin typeface="Space Grotesk"/>
-                <a:ea typeface="Space Grotesk"/>
-                <a:cs typeface="Space Grotesk"/>
+                <a:latin typeface="Space Mono"/>
+                <a:ea typeface="Space Mono"/>
+                <a:cs typeface="Space Mono"/>
               </a:defRPr>
             </a:lvl1pPr>
           </a:lstStyle>
@@ -1067,7 +1067,7 @@
         </p:nvSpPr>
         <p:spPr>
           <a:xfrm>
-            <a:off x="571500" y="457200"/>
+            <a:off x="571500" y="571500"/>
             <a:ext cx="8001000" cy="838200"/>
           </a:xfrm>
           <a:prstGeom prst="rect">
@@ -1214,7 +1214,7 @@
         </p:nvSpPr>
         <p:spPr>
           <a:xfrm>
-            <a:off x="571500" y="457200"/>
+            <a:off x="571500" y="571500"/>
             <a:ext cx="8001000" cy="457200"/>
           </a:xfrm>
           <a:prstGeom prst="rect">
@@ -1260,12 +1260,12 @@
         </p:nvSpPr>
         <p:spPr>
           <a:xfrm>
-            <a:off x="571500" y="1104900"/>
-            <a:ext cx="8001000" cy="3581400"/>
+            <a:off x="571500" y="1219200"/>
+            <a:ext cx="8001000" cy="3467100"/>
           </a:xfrm>
           <a:prstGeom prst="roundRect">
             <a:avLst>
-              <a:gd name="adj" fmla="val 2128"/>
+              <a:gd name="adj" fmla="val 2198"/>
             </a:avLst>
           </a:prstGeom>
           <a:solidFill>
@@ -1293,8 +1293,8 @@
         </p:nvSpPr>
         <p:spPr>
           <a:xfrm>
-            <a:off x="762000" y="1295400"/>
-            <a:ext cx="7620000" cy="3200400"/>
+            <a:off x="762000" y="1409700"/>
+            <a:ext cx="7620000" cy="3086100"/>
           </a:xfrm>
           <a:prstGeom prst="rect">
             <a:avLst/>
@@ -1355,7 +1355,7 @@
         </p:nvSpPr>
         <p:spPr>
           <a:xfrm>
-            <a:off x="571500" y="457200"/>
+            <a:off x="571500" y="571500"/>
             <a:ext cx="8001000" cy="457200"/>
           </a:xfrm>
           <a:prstGeom prst="rect">
@@ -1410,7 +1410,7 @@
             </a:avLst>
           </a:prstGeom>
           <a:solidFill>
-            <a:srgbClr val="F4F4F4"/>
+            <a:srgbClr val="FFFCFC"/>
           </a:solidFill>
           <a:ln>
             <a:noFill/>
@@ -1615,7 +1615,7 @@
             </a:avLst>
           </a:prstGeom>
           <a:solidFill>
-            <a:srgbClr val="F4F4F4"/>
+            <a:srgbClr val="FFFCFC"/>
           </a:solidFill>
           <a:ln>
             <a:noFill/>
@@ -1820,7 +1820,7 @@
             </a:avLst>
           </a:prstGeom>
           <a:solidFill>
-            <a:srgbClr val="F4F4F4"/>
+            <a:srgbClr val="FFFCFC"/>
           </a:solidFill>
           <a:ln>
             <a:noFill/>
@@ -2204,7 +2204,7 @@
         </p:nvSpPr>
         <p:spPr>
           <a:xfrm>
-            <a:off x="571500" y="457200"/>
+            <a:off x="571500" y="571500"/>
             <a:ext cx="8001000" cy="457200"/>
           </a:xfrm>
           <a:prstGeom prst="rect">
@@ -2615,7 +2615,7 @@
         </p:nvSpPr>
         <p:spPr>
           <a:xfrm>
-            <a:off x="571500" y="457200"/>
+            <a:off x="571500" y="571500"/>
             <a:ext cx="8001000" cy="457200"/>
           </a:xfrm>
           <a:prstGeom prst="rect">
@@ -2672,7 +2672,7 @@
     <p:bg>
       <p:bgPr>
         <a:solidFill>
-          <a:srgbClr val="FFFCFC"/>
+          <a:srgbClr val="EBECFE"/>
         </a:solidFill>
         <a:effectLst/>
       </p:bgPr>
@@ -3201,23 +3201,44 @@
         </p:nvSpPr>
         <p:spPr/>
         <p:txBody>
+          <a:bodyPr anchor="b"/>
+          <a:lstStyle/>
+          <a:p>
+            <a:r>
+              <a:t>Building on Ethereum with agents</a:t>
+            </a:r>
+          </a:p>
+        </p:txBody>
+      </p:sp>
+      <p:sp>
+        <p:nvSpPr>
+          <p:cNvPr id="3" name="Text Placeholder 2"/>
+          <p:cNvSpPr>
+            <a:spLocks noGrp="1"/>
+          </p:cNvSpPr>
+          <p:nvPr>
+            <p:ph type="body" idx="1"/>
+          </p:nvPr>
+        </p:nvSpPr>
+        <p:spPr/>
+        <p:txBody>
           <a:bodyPr/>
           <a:lstStyle/>
           <a:p>
             <a:r>
-              <a:t>Building on Ethereum with agents</a:t>
-            </a:r>
-          </a:p>
-        </p:txBody>
-      </p:sp>
-      <p:sp>
-        <p:nvSpPr>
-          <p:cNvPr id="3" name="Text Placeholder 2"/>
-          <p:cNvSpPr>
-            <a:spLocks noGrp="1"/>
-          </p:cNvSpPr>
-          <p:nvPr>
-            <p:ph type="body" idx="1"/>
+              <a:t>Shiv Bhonde</a:t>
+            </a:r>
+          </a:p>
+        </p:txBody>
+      </p:sp>
+      <p:sp>
+        <p:nvSpPr>
+          <p:cNvPr id="4" name="Text Placeholder 3"/>
+          <p:cNvSpPr>
+            <a:spLocks noGrp="1"/>
+          </p:cNvSpPr>
+          <p:nvPr>
+            <p:ph type="body" idx="2"/>
           </p:nvPr>
         </p:nvSpPr>
         <p:spPr/>
@@ -3226,28 +3247,7 @@
           <a:lstStyle/>
           <a:p>
             <a:r>
-              <a:t>Shiv Bhonde</a:t>
-            </a:r>
-          </a:p>
-        </p:txBody>
-      </p:sp>
-      <p:sp>
-        <p:nvSpPr>
-          <p:cNvPr id="4" name="Text Placeholder 3"/>
-          <p:cNvSpPr>
-            <a:spLocks noGrp="1"/>
-          </p:cNvSpPr>
-          <p:nvPr>
-            <p:ph type="body" idx="2"/>
-          </p:nvPr>
-        </p:nvSpPr>
-        <p:spPr/>
-        <p:txBody>
-          <a:bodyPr/>
-          <a:lstStyle/>
-          <a:p>
-            <a:r>
-              <a:t>BuidlGuidl · @shivbhonde</a:t>
+              <a:t>@shivbhonde</a:t>
             </a:r>
           </a:p>
         </p:txBody>
@@ -3278,7 +3278,7 @@
         </p:nvSpPr>
         <p:spPr>
           <a:xfrm>
-            <a:off x="552450" y="2776538"/>
+            <a:off x="552450" y="3271838"/>
             <a:ext cx="1695450" cy="300038"/>
           </a:xfrm>
           <a:prstGeom prst="roundRect">
@@ -3328,7 +3328,7 @@
         </p:nvSpPr>
         <p:spPr/>
         <p:txBody>
-          <a:bodyPr/>
+          <a:bodyPr anchor="b"/>
           <a:lstStyle/>
           <a:p>
             <a:r>
@@ -3430,32 +3430,32 @@
         </p:nvSpPr>
         <p:spPr/>
         <p:txBody>
+          <a:bodyPr anchor="b"/>
+          <a:lstStyle/>
+          <a:p>
+            <a:r>
+              <a:t>Building on Ethereum with agents</a:t>
+            </a:r>
+          </a:p>
+        </p:txBody>
+      </p:sp>
+      <p:sp>
+        <p:nvSpPr>
+          <p:cNvPr id="3" name="Text Placeholder 2"/>
+          <p:cNvSpPr>
+            <a:spLocks noGrp="1"/>
+          </p:cNvSpPr>
+          <p:nvPr>
+            <p:ph type="body" idx="1"/>
+          </p:nvPr>
+        </p:nvSpPr>
+        <p:spPr/>
+        <p:txBody>
           <a:bodyPr/>
           <a:lstStyle/>
           <a:p>
             <a:r>
-              <a:t>Building on Ethereum with agents</a:t>
-            </a:r>
-          </a:p>
-        </p:txBody>
-      </p:sp>
-      <p:sp>
-        <p:nvSpPr>
-          <p:cNvPr id="3" name="Text Placeholder 2"/>
-          <p:cNvSpPr>
-            <a:spLocks noGrp="1"/>
-          </p:cNvSpPr>
-          <p:nvPr>
-            <p:ph type="body" idx="1"/>
-          </p:nvPr>
-        </p:nvSpPr>
-        <p:spPr/>
-        <p:txBody>
-          <a:bodyPr/>
-          <a:lstStyle/>
-          <a:p>
-            <a:r>
-              <a:t>Shiv Bhonde, BuidlGuidl</a:t>
+              <a:t>Shiv Bhonde</a:t>
             </a:r>
           </a:p>
         </p:txBody>
@@ -3717,12 +3717,12 @@
         </p:blipFill>
         <p:spPr>
           <a:xfrm>
-            <a:off x="2128838" y="1114425"/>
-            <a:ext cx="4886325" cy="3562350"/>
+            <a:off x="2457450" y="1409700"/>
+            <a:ext cx="4233862" cy="3086100"/>
           </a:xfrm>
           <a:prstGeom prst="roundRect">
             <a:avLst>
-              <a:gd name="adj" fmla="val 1604"/>
+              <a:gd name="adj" fmla="val 1852"/>
             </a:avLst>
           </a:prstGeom>
         </p:spPr>
@@ -4653,7 +4653,7 @@
         <a:srgbClr val="182232"/>
       </a:dk2>
       <a:lt2>
-        <a:srgbClr val="F4F4F4"/>
+        <a:srgbClr val="EBECFE"/>
       </a:lt2>
       <a:accent1>
         <a:srgbClr val="808CFF"/>

</xml_diff>

<commit_message>
Cover title: two lines in a 1150 wide box above the art
The title box was 840 wide, so titles folded after two or three words
and stacked four lines tall. It is now 1150 wide and ends at y 440, in
the open sky above the art: every talk title on the day fits in two
lines. The speaker block moves up to 496 and 560; Closing and Up next
use the same positions, so the three cover slides line up. SKILL.md
says a title that needs three lines drops to 80 px on 84 px spacing.

Co-Authored-By: Claude Opus 5.5 <noreply@anthropic.com>
</commit_message>
<xml_diff>
--- a/template/buidlguidl-devcon8.pptx
+++ b/template/buidlguidl-devcon8.pptx
@@ -206,7 +206,7 @@
         <p:spPr>
           <a:xfrm>
             <a:off x="571500" y="895350"/>
-            <a:ext cx="4000500" cy="1924050"/>
+            <a:ext cx="5476875" cy="1200150"/>
           </a:xfrm>
           <a:prstGeom prst="rect">
             <a:avLst/>
@@ -255,7 +255,7 @@
         </p:nvSpPr>
         <p:spPr>
           <a:xfrm>
-            <a:off x="571500" y="3086100"/>
+            <a:off x="571500" y="2362200"/>
             <a:ext cx="4000500" cy="295275"/>
           </a:xfrm>
           <a:prstGeom prst="rect">
@@ -305,7 +305,7 @@
         </p:nvSpPr>
         <p:spPr>
           <a:xfrm>
-            <a:off x="571500" y="3390900"/>
+            <a:off x="571500" y="2667000"/>
             <a:ext cx="4000500" cy="223838"/>
           </a:xfrm>
           <a:prstGeom prst="rect">
@@ -445,7 +445,7 @@
         <p:spPr>
           <a:xfrm>
             <a:off x="571500" y="895350"/>
-            <a:ext cx="4000500" cy="1352550"/>
+            <a:ext cx="5476875" cy="1200150"/>
           </a:xfrm>
           <a:prstGeom prst="rect">
             <a:avLst/>
@@ -494,7 +494,7 @@
         </p:nvSpPr>
         <p:spPr>
           <a:xfrm>
-            <a:off x="571500" y="2514600"/>
+            <a:off x="571500" y="2362200"/>
             <a:ext cx="4000500" cy="295275"/>
           </a:xfrm>
           <a:prstGeom prst="rect">
@@ -544,7 +544,7 @@
         </p:nvSpPr>
         <p:spPr>
           <a:xfrm>
-            <a:off x="571500" y="2819400"/>
+            <a:off x="571500" y="2667000"/>
             <a:ext cx="4000500" cy="223838"/>
           </a:xfrm>
           <a:prstGeom prst="rect">
@@ -594,7 +594,7 @@
         </p:nvSpPr>
         <p:spPr>
           <a:xfrm>
-            <a:off x="571500" y="3276600"/>
+            <a:off x="571500" y="3124200"/>
             <a:ext cx="4000500" cy="295275"/>
           </a:xfrm>
           <a:prstGeom prst="rect">
@@ -734,7 +734,7 @@
         <p:spPr>
           <a:xfrm>
             <a:off x="571500" y="895350"/>
-            <a:ext cx="4000500" cy="1924050"/>
+            <a:ext cx="5476875" cy="1200150"/>
           </a:xfrm>
           <a:prstGeom prst="rect">
             <a:avLst/>
@@ -783,7 +783,7 @@
         </p:nvSpPr>
         <p:spPr>
           <a:xfrm>
-            <a:off x="571500" y="3086100"/>
+            <a:off x="571500" y="2362200"/>
             <a:ext cx="4000500" cy="295275"/>
           </a:xfrm>
           <a:prstGeom prst="rect">
@@ -833,7 +833,7 @@
         </p:nvSpPr>
         <p:spPr>
           <a:xfrm>
-            <a:off x="571500" y="3390900"/>
+            <a:off x="571500" y="2667000"/>
             <a:ext cx="4000500" cy="223838"/>
           </a:xfrm>
           <a:prstGeom prst="rect">
@@ -3278,7 +3278,7 @@
         </p:nvSpPr>
         <p:spPr>
           <a:xfrm>
-            <a:off x="552450" y="3271838"/>
+            <a:off x="552450" y="3119438"/>
             <a:ext cx="1695450" cy="300038"/>
           </a:xfrm>
           <a:prstGeom prst="roundRect">

</xml_diff>